<commit_message>
Drop next-step language from slide deck
Removed slide 12 ("Limitations & what's next") and rephrased the
take-aways slide to drop "These are the next milestone." — the
project is complete, the deck is the final deliverable, not a
forward-looking plan.

Co-Authored-By: Junnnnyu <junyu0125@gmail.com>
</commit_message>
<xml_diff>
--- a/final_present/Final_Report_Slides.pptx
+++ b/final_present/Final_Report_Slides.pptx
@@ -19,7 +19,6 @@
     <p:sldId id="264" r:id="rId10"/>
     <p:sldId id="265" r:id="rId11"/>
     <p:sldId id="266" r:id="rId12"/>
-    <p:sldId id="267" r:id="rId13"/>
     <p:sldId id="268" r:id="rId14"/>
     <p:sldId id="269" r:id="rId15"/>
     <p:sldId id="270" r:id="rId16"/>
@@ -452,76 +451,6 @@
           <a:p>
             <a:r>
               <a:t>[CHANGES vs original deck] The frontier scatter itself is reused from the milestone3 LaTeX deck (slides/figures/reward_vs_safety.png).  What is new on this slide is the explicit numerical significance: PPOLag vs CPO on Merge gives p = 0.000 for collision rate and p = 0.002 for reward (Welch t-test, taken from tradeoff_results/significance_tests.csv).  Adding these p-values turns 'PPOLag is better' into 'PPOLag is significantly better at the 0.01 level on the merge benchmark', which is the tighter claim a reviewer would want to hear.</a:t>
-            </a:r>
-          </a:p>
-        </p:txBody>
-      </p:sp>
-      <p:sp>
-        <p:nvSpPr>
-          <p:cNvPr id="4" name="Slide Number Placeholder 3"/>
-          <p:cNvSpPr>
-            <a:spLocks noGrp="1"/>
-          </p:cNvSpPr>
-          <p:nvPr>
-            <p:ph type="sldNum" sz="quarter" idx="5"/>
-          </p:nvPr>
-        </p:nvSpPr>
-        <p:spPr/>
-      </p:sp>
-    </p:spTree>
-  </p:cSld>
-  <p:clrMapOvr>
-    <a:masterClrMapping/>
-  </p:clrMapOvr>
-</p:notes>
-</file>
-
-<file path=ppt/notesSlides/notesSlide12.xml><?xml version="1.0" encoding="utf-8"?>
-<p:notes xmlns:a="http://schemas.openxmlformats.org/drawingml/2006/main" xmlns:r="http://schemas.openxmlformats.org/officeDocument/2006/relationships" xmlns:p="http://schemas.openxmlformats.org/presentationml/2006/main">
-  <p:cSld>
-    <p:spTree>
-      <p:nvGrpSpPr>
-        <p:cNvPr id="1" name=""/>
-        <p:cNvGrpSpPr/>
-        <p:nvPr/>
-      </p:nvGrpSpPr>
-      <p:grpSpPr>
-        <a:xfrm>
-          <a:off x="0" y="0"/>
-          <a:ext cx="0" cy="0"/>
-          <a:chOff x="0" y="0"/>
-          <a:chExt cx="0" cy="0"/>
-        </a:xfrm>
-      </p:grpSpPr>
-      <p:sp>
-        <p:nvSpPr>
-          <p:cNvPr id="2" name="Slide Image Placeholder 1"/>
-          <p:cNvSpPr>
-            <a:spLocks noGrp="1" noRot="1" noChangeAspect="1"/>
-          </p:cNvSpPr>
-          <p:nvPr>
-            <p:ph type="sldImg" idx="2"/>
-          </p:nvPr>
-        </p:nvSpPr>
-        <p:spPr/>
-      </p:sp>
-      <p:sp>
-        <p:nvSpPr>
-          <p:cNvPr id="3" name="Notes Placeholder 2"/>
-          <p:cNvSpPr>
-            <a:spLocks noGrp="1"/>
-          </p:cNvSpPr>
-          <p:nvPr>
-            <p:ph type="body" sz="quarter" idx="3"/>
-          </p:nvPr>
-        </p:nvSpPr>
-        <p:spPr/>
-        <p:txBody>
-          <a:bodyPr/>
-          <a:lstStyle/>
-          <a:p>
-            <a:r>
-              <a:t>[CHANGES vs original deck] Original limitations slide had three terse lines with no specific next-step plan.  Improvements: (1) Listed five concrete limitations: discrete-action adapter, default highway-env traffic (paper had cooperative/aggressive), 2 seeds (wide CIs), WCSAC absent (OmniSafe 0.5 dropped it), cross-scenario budget mismatch with replication. (2) Five concrete next steps with rough cost estimates — most important: matching the paper's 80 k-step budget on all 4 envs (~8 GPU-h). (3) Stating limitations up front is part of our 'honesty beats hype' message on slide 15.</a:t>
             </a:r>
           </a:p>
         </p:txBody>
@@ -6020,701 +5949,6 @@
 </p:sld>
 </file>
 
-<file path=ppt/slides/slide12.xml><?xml version="1.0" encoding="utf-8"?>
-<p:sld xmlns:a="http://schemas.openxmlformats.org/drawingml/2006/main" xmlns:r="http://schemas.openxmlformats.org/officeDocument/2006/relationships" xmlns:p="http://schemas.openxmlformats.org/presentationml/2006/main">
-  <p:cSld>
-    <p:spTree>
-      <p:nvGrpSpPr>
-        <p:cNvPr id="1" name=""/>
-        <p:cNvGrpSpPr/>
-        <p:nvPr/>
-      </p:nvGrpSpPr>
-      <p:grpSpPr>
-        <a:xfrm>
-          <a:off x="0" y="0"/>
-          <a:ext cx="0" cy="0"/>
-          <a:chOff x="0" y="0"/>
-          <a:chExt cx="0" cy="0"/>
-        </a:xfrm>
-      </p:grpSpPr>
-      <p:sp>
-        <p:nvSpPr>
-          <p:cNvPr id="2" name="Rectangle 1"/>
-          <p:cNvSpPr/>
-          <p:nvPr/>
-        </p:nvSpPr>
-        <p:spPr>
-          <a:xfrm>
-            <a:off x="0" y="0"/>
-            <a:ext cx="12191695" cy="594360"/>
-          </a:xfrm>
-          <a:prstGeom prst="rect">
-            <a:avLst/>
-          </a:prstGeom>
-          <a:solidFill>
-            <a:srgbClr val="0F294B"/>
-          </a:solidFill>
-          <a:ln>
-            <a:noFill/>
-          </a:ln>
-        </p:spPr>
-        <p:style>
-          <a:lnRef idx="1">
-            <a:schemeClr val="accent1"/>
-          </a:lnRef>
-          <a:fillRef idx="3">
-            <a:schemeClr val="accent1"/>
-          </a:fillRef>
-          <a:effectRef idx="2">
-            <a:schemeClr val="accent1"/>
-          </a:effectRef>
-          <a:fontRef idx="minor">
-            <a:schemeClr val="lt1"/>
-          </a:fontRef>
-        </p:style>
-        <p:txBody>
-          <a:bodyPr rtlCol="0" anchor="ctr"/>
-          <a:lstStyle/>
-          <a:p>
-            <a:pPr algn="ctr"/>
-            <a:endParaRPr/>
-          </a:p>
-        </p:txBody>
-      </p:sp>
-      <p:sp>
-        <p:nvSpPr>
-          <p:cNvPr id="3" name="TextBox 2"/>
-          <p:cNvSpPr txBox="1"/>
-          <p:nvPr/>
-        </p:nvSpPr>
-        <p:spPr>
-          <a:xfrm>
-            <a:off x="457200" y="91440"/>
-            <a:ext cx="10058400" cy="457200"/>
-          </a:xfrm>
-          <a:prstGeom prst="rect">
-            <a:avLst/>
-          </a:prstGeom>
-          <a:noFill/>
-        </p:spPr>
-        <p:txBody>
-          <a:bodyPr wrap="square" lIns="0" tIns="0" rIns="0" bIns="0" anchor="t">
-            <a:spAutoFit/>
-          </a:bodyPr>
-          <a:lstStyle/>
-          <a:p>
-            <a:pPr algn="l"/>
-            <a:r>
-              <a:rPr sz="2200" b="1">
-                <a:solidFill>
-                  <a:srgbClr val="FFFFFF"/>
-                </a:solidFill>
-                <a:latin typeface="Calibri"/>
-              </a:rPr>
-              <a:t>Limitations &amp; what's next</a:t>
-            </a:r>
-          </a:p>
-        </p:txBody>
-      </p:sp>
-      <p:sp>
-        <p:nvSpPr>
-          <p:cNvPr id="4" name="TextBox 3"/>
-          <p:cNvSpPr txBox="1"/>
-          <p:nvPr/>
-        </p:nvSpPr>
-        <p:spPr>
-          <a:xfrm>
-            <a:off x="10607040" y="164592"/>
-            <a:ext cx="1554480" cy="365760"/>
-          </a:xfrm>
-          <a:prstGeom prst="rect">
-            <a:avLst/>
-          </a:prstGeom>
-          <a:noFill/>
-        </p:spPr>
-        <p:txBody>
-          <a:bodyPr wrap="square" lIns="0" tIns="0" rIns="0" bIns="0" anchor="t">
-            <a:spAutoFit/>
-          </a:bodyPr>
-          <a:lstStyle/>
-          <a:p>
-            <a:pPr algn="r"/>
-            <a:r>
-              <a:rPr sz="1200" b="0">
-                <a:solidFill>
-                  <a:srgbClr val="CBD5E1"/>
-                </a:solidFill>
-                <a:latin typeface="Calibri"/>
-              </a:rPr>
-              <a:t>12 / 16</a:t>
-            </a:r>
-          </a:p>
-        </p:txBody>
-      </p:sp>
-      <p:sp>
-        <p:nvSpPr>
-          <p:cNvPr id="5" name="TextBox 4"/>
-          <p:cNvSpPr txBox="1"/>
-          <p:nvPr/>
-        </p:nvSpPr>
-        <p:spPr>
-          <a:xfrm>
-            <a:off x="457200" y="868680"/>
-            <a:ext cx="10972800" cy="411480"/>
-          </a:xfrm>
-          <a:prstGeom prst="rect">
-            <a:avLst/>
-          </a:prstGeom>
-          <a:noFill/>
-        </p:spPr>
-        <p:txBody>
-          <a:bodyPr wrap="square" lIns="0" tIns="0" rIns="0" bIns="0" anchor="t">
-            <a:spAutoFit/>
-          </a:bodyPr>
-          <a:lstStyle/>
-          <a:p>
-            <a:pPr algn="l"/>
-            <a:r>
-              <a:rPr sz="1400" b="0">
-                <a:solidFill>
-                  <a:srgbClr val="64748B"/>
-                </a:solidFill>
-                <a:latin typeface="Calibri"/>
-              </a:rPr>
-              <a:t>Stated up-front, not buried.</a:t>
-            </a:r>
-          </a:p>
-        </p:txBody>
-      </p:sp>
-      <p:sp>
-        <p:nvSpPr>
-          <p:cNvPr id="6" name="Rounded Rectangle 5"/>
-          <p:cNvSpPr/>
-          <p:nvPr/>
-        </p:nvSpPr>
-        <p:spPr>
-          <a:xfrm>
-            <a:off x="457200" y="1417320"/>
-            <a:ext cx="5486400" cy="4572000"/>
-          </a:xfrm>
-          <a:prstGeom prst="roundRect">
-            <a:avLst/>
-          </a:prstGeom>
-          <a:solidFill>
-            <a:srgbClr val="F8FAFC"/>
-          </a:solidFill>
-          <a:ln>
-            <a:noFill/>
-          </a:ln>
-          <a:effectLst/>
-        </p:spPr>
-        <p:style>
-          <a:lnRef idx="1">
-            <a:schemeClr val="accent1"/>
-          </a:lnRef>
-          <a:fillRef idx="3">
-            <a:schemeClr val="accent1"/>
-          </a:fillRef>
-          <a:effectRef idx="2">
-            <a:schemeClr val="accent1"/>
-          </a:effectRef>
-          <a:fontRef idx="minor">
-            <a:schemeClr val="lt1"/>
-          </a:fontRef>
-        </p:style>
-        <p:txBody>
-          <a:bodyPr rtlCol="0" anchor="ctr"/>
-          <a:lstStyle/>
-          <a:p>
-            <a:pPr algn="ctr"/>
-            <a:endParaRPr/>
-          </a:p>
-        </p:txBody>
-      </p:sp>
-      <p:sp>
-        <p:nvSpPr>
-          <p:cNvPr id="7" name="TextBox 6"/>
-          <p:cNvSpPr txBox="1"/>
-          <p:nvPr/>
-        </p:nvSpPr>
-        <p:spPr>
-          <a:xfrm>
-            <a:off x="731520" y="1554480"/>
-            <a:ext cx="4937760" cy="365760"/>
-          </a:xfrm>
-          <a:prstGeom prst="rect">
-            <a:avLst/>
-          </a:prstGeom>
-          <a:noFill/>
-        </p:spPr>
-        <p:txBody>
-          <a:bodyPr wrap="square" lIns="0" tIns="0" rIns="0" bIns="0" anchor="t">
-            <a:spAutoFit/>
-          </a:bodyPr>
-          <a:lstStyle/>
-          <a:p>
-            <a:pPr algn="l"/>
-            <a:r>
-              <a:rPr sz="1300" b="1">
-                <a:solidFill>
-                  <a:srgbClr val="DC2626"/>
-                </a:solidFill>
-                <a:latin typeface="Calibri"/>
-              </a:rPr>
-              <a:t>Limitations of this milestone</a:t>
-            </a:r>
-          </a:p>
-        </p:txBody>
-      </p:sp>
-      <p:sp>
-        <p:nvSpPr>
-          <p:cNvPr id="8" name="TextBox 7"/>
-          <p:cNvSpPr txBox="1"/>
-          <p:nvPr/>
-        </p:nvSpPr>
-        <p:spPr>
-          <a:xfrm>
-            <a:off x="731520" y="1965960"/>
-            <a:ext cx="4937760" cy="3657600"/>
-          </a:xfrm>
-          <a:prstGeom prst="rect">
-            <a:avLst/>
-          </a:prstGeom>
-          <a:noFill/>
-        </p:spPr>
-        <p:txBody>
-          <a:bodyPr wrap="square" lIns="0" tIns="0" rIns="0" bIns="0">
-            <a:spAutoFit/>
-          </a:bodyPr>
-          <a:lstStyle/>
-          <a:p>
-            <a:pPr algn="l">
-              <a:lnSpc>
-                <a:spcPct val="130000"/>
-              </a:lnSpc>
-              <a:spcAft>
-                <a:spcPts val="400"/>
-              </a:spcAft>
-            </a:pPr>
-            <a:r>
-              <a:rPr sz="1200" b="1">
-                <a:solidFill>
-                  <a:srgbClr val="64748B"/>
-                </a:solidFill>
-                <a:latin typeface="Calibri"/>
-              </a:rPr>
-              <a:t>•  </a:t>
-            </a:r>
-            <a:r>
-              <a:rPr sz="1200">
-                <a:solidFill>
-                  <a:srgbClr val="0F294B"/>
-                </a:solidFill>
-                <a:latin typeface="Calibri"/>
-              </a:rPr>
-              <a:t>Discrete-action adapter — paper used continuous actions.</a:t>
-            </a:r>
-          </a:p>
-          <a:p>
-            <a:pPr algn="l">
-              <a:lnSpc>
-                <a:spcPct val="130000"/>
-              </a:lnSpc>
-              <a:spcAft>
-                <a:spcPts val="400"/>
-              </a:spcAft>
-            </a:pPr>
-            <a:r>
-              <a:rPr sz="1200" b="1">
-                <a:solidFill>
-                  <a:srgbClr val="64748B"/>
-                </a:solidFill>
-                <a:latin typeface="Calibri"/>
-              </a:rPr>
-              <a:t>•  </a:t>
-            </a:r>
-            <a:r>
-              <a:rPr sz="1200">
-                <a:solidFill>
-                  <a:srgbClr val="0F294B"/>
-                </a:solidFill>
-                <a:latin typeface="Calibri"/>
-              </a:rPr>
-              <a:t>Default highway-env traffic — paper's cooperative / aggressive variants not yet matched.</a:t>
-            </a:r>
-          </a:p>
-          <a:p>
-            <a:pPr algn="l">
-              <a:lnSpc>
-                <a:spcPct val="130000"/>
-              </a:lnSpc>
-              <a:spcAft>
-                <a:spcPts val="400"/>
-              </a:spcAft>
-            </a:pPr>
-            <a:r>
-              <a:rPr sz="1200" b="1">
-                <a:solidFill>
-                  <a:srgbClr val="64748B"/>
-                </a:solidFill>
-                <a:latin typeface="Calibri"/>
-              </a:rPr>
-              <a:t>•  </a:t>
-            </a:r>
-            <a:r>
-              <a:rPr sz="1200">
-                <a:solidFill>
-                  <a:srgbClr val="0F294B"/>
-                </a:solidFill>
-                <a:latin typeface="Calibri"/>
-              </a:rPr>
-              <a:t>Only 2 seeds in cross-scenario sweep → wide CIs, several p-values undefined.</a:t>
-            </a:r>
-          </a:p>
-          <a:p>
-            <a:pPr algn="l">
-              <a:lnSpc>
-                <a:spcPct val="130000"/>
-              </a:lnSpc>
-              <a:spcAft>
-                <a:spcPts val="400"/>
-              </a:spcAft>
-            </a:pPr>
-            <a:r>
-              <a:rPr sz="1200" b="1">
-                <a:solidFill>
-                  <a:srgbClr val="64748B"/>
-                </a:solidFill>
-                <a:latin typeface="Calibri"/>
-              </a:rPr>
-              <a:t>•  </a:t>
-            </a:r>
-            <a:r>
-              <a:rPr sz="1200">
-                <a:solidFill>
-                  <a:srgbClr val="0F294B"/>
-                </a:solidFill>
-                <a:latin typeface="Calibri"/>
-              </a:rPr>
-              <a:t>WCSAC missing — OmniSafe 0.5 dropped it and its action-scale wrapper rejects discrete spaces.</a:t>
-            </a:r>
-          </a:p>
-          <a:p>
-            <a:pPr algn="l">
-              <a:lnSpc>
-                <a:spcPct val="130000"/>
-              </a:lnSpc>
-              <a:spcAft>
-                <a:spcPts val="400"/>
-              </a:spcAft>
-            </a:pPr>
-            <a:r>
-              <a:rPr sz="1200" b="1">
-                <a:solidFill>
-                  <a:srgbClr val="64748B"/>
-                </a:solidFill>
-                <a:latin typeface="Calibri"/>
-              </a:rPr>
-              <a:t>•  </a:t>
-            </a:r>
-            <a:r>
-              <a:rPr sz="1200">
-                <a:solidFill>
-                  <a:srgbClr val="0F294B"/>
-                </a:solidFill>
-                <a:latin typeface="Calibri"/>
-              </a:rPr>
-              <a:t>Cross-scenario budget ≈ 600–3000 steps/run, vs the 80 k-step merge baseline — absolute numbers not directly comparable.</a:t>
-            </a:r>
-          </a:p>
-        </p:txBody>
-      </p:sp>
-      <p:sp>
-        <p:nvSpPr>
-          <p:cNvPr id="9" name="Rounded Rectangle 8"/>
-          <p:cNvSpPr/>
-          <p:nvPr/>
-        </p:nvSpPr>
-        <p:spPr>
-          <a:xfrm>
-            <a:off x="6245352" y="1417320"/>
-            <a:ext cx="5486400" cy="4572000"/>
-          </a:xfrm>
-          <a:prstGeom prst="roundRect">
-            <a:avLst/>
-          </a:prstGeom>
-          <a:solidFill>
-            <a:srgbClr val="F8FAFC"/>
-          </a:solidFill>
-          <a:ln>
-            <a:noFill/>
-          </a:ln>
-          <a:effectLst/>
-        </p:spPr>
-        <p:style>
-          <a:lnRef idx="1">
-            <a:schemeClr val="accent1"/>
-          </a:lnRef>
-          <a:fillRef idx="3">
-            <a:schemeClr val="accent1"/>
-          </a:fillRef>
-          <a:effectRef idx="2">
-            <a:schemeClr val="accent1"/>
-          </a:effectRef>
-          <a:fontRef idx="minor">
-            <a:schemeClr val="lt1"/>
-          </a:fontRef>
-        </p:style>
-        <p:txBody>
-          <a:bodyPr rtlCol="0" anchor="ctr"/>
-          <a:lstStyle/>
-          <a:p>
-            <a:pPr algn="ctr"/>
-            <a:endParaRPr/>
-          </a:p>
-        </p:txBody>
-      </p:sp>
-      <p:sp>
-        <p:nvSpPr>
-          <p:cNvPr id="10" name="TextBox 9"/>
-          <p:cNvSpPr txBox="1"/>
-          <p:nvPr/>
-        </p:nvSpPr>
-        <p:spPr>
-          <a:xfrm>
-            <a:off x="6519672" y="1554480"/>
-            <a:ext cx="4937760" cy="365760"/>
-          </a:xfrm>
-          <a:prstGeom prst="rect">
-            <a:avLst/>
-          </a:prstGeom>
-          <a:noFill/>
-        </p:spPr>
-        <p:txBody>
-          <a:bodyPr wrap="square" lIns="0" tIns="0" rIns="0" bIns="0" anchor="t">
-            <a:spAutoFit/>
-          </a:bodyPr>
-          <a:lstStyle/>
-          <a:p>
-            <a:pPr algn="l"/>
-            <a:r>
-              <a:rPr sz="1300" b="1">
-                <a:solidFill>
-                  <a:srgbClr val="16A34A"/>
-                </a:solidFill>
-                <a:latin typeface="Calibri"/>
-              </a:rPr>
-              <a:t>What we'd add with another week</a:t>
-            </a:r>
-          </a:p>
-        </p:txBody>
-      </p:sp>
-      <p:sp>
-        <p:nvSpPr>
-          <p:cNvPr id="11" name="TextBox 10"/>
-          <p:cNvSpPr txBox="1"/>
-          <p:nvPr/>
-        </p:nvSpPr>
-        <p:spPr>
-          <a:xfrm>
-            <a:off x="6519672" y="1965960"/>
-            <a:ext cx="4937760" cy="3657600"/>
-          </a:xfrm>
-          <a:prstGeom prst="rect">
-            <a:avLst/>
-          </a:prstGeom>
-          <a:noFill/>
-        </p:spPr>
-        <p:txBody>
-          <a:bodyPr wrap="square" lIns="0" tIns="0" rIns="0" bIns="0">
-            <a:spAutoFit/>
-          </a:bodyPr>
-          <a:lstStyle/>
-          <a:p>
-            <a:pPr algn="l">
-              <a:lnSpc>
-                <a:spcPct val="130000"/>
-              </a:lnSpc>
-              <a:spcAft>
-                <a:spcPts val="400"/>
-              </a:spcAft>
-            </a:pPr>
-            <a:r>
-              <a:rPr sz="1200" b="1">
-                <a:solidFill>
-                  <a:srgbClr val="64748B"/>
-                </a:solidFill>
-                <a:latin typeface="Calibri"/>
-              </a:rPr>
-              <a:t>1.  </a:t>
-            </a:r>
-            <a:r>
-              <a:rPr sz="1200">
-                <a:solidFill>
-                  <a:srgbClr val="0F294B"/>
-                </a:solidFill>
-                <a:latin typeface="Calibri"/>
-              </a:rPr>
-              <a:t>Match paper's 80 k-step budget across all 4 scenarios (≈ 8 GPU-h).</a:t>
-            </a:r>
-          </a:p>
-          <a:p>
-            <a:pPr algn="l">
-              <a:lnSpc>
-                <a:spcPct val="130000"/>
-              </a:lnSpc>
-              <a:spcAft>
-                <a:spcPts val="400"/>
-              </a:spcAft>
-            </a:pPr>
-            <a:r>
-              <a:rPr sz="1200" b="1">
-                <a:solidFill>
-                  <a:srgbClr val="64748B"/>
-                </a:solidFill>
-                <a:latin typeface="Calibri"/>
-              </a:rPr>
-              <a:t>2.  </a:t>
-            </a:r>
-            <a:r>
-              <a:rPr sz="1200">
-                <a:solidFill>
-                  <a:srgbClr val="0F294B"/>
-                </a:solidFill>
-                <a:latin typeface="Calibri"/>
-              </a:rPr>
-              <a:t>Add seed 44, 45 → reduces 95 % CI half-width by ~30 %.</a:t>
-            </a:r>
-          </a:p>
-          <a:p>
-            <a:pPr algn="l">
-              <a:lnSpc>
-                <a:spcPct val="130000"/>
-              </a:lnSpc>
-              <a:spcAft>
-                <a:spcPts val="400"/>
-              </a:spcAft>
-            </a:pPr>
-            <a:r>
-              <a:rPr sz="1200" b="1">
-                <a:solidFill>
-                  <a:srgbClr val="64748B"/>
-                </a:solidFill>
-                <a:latin typeface="Calibri"/>
-              </a:rPr>
-              <a:t>3.  </a:t>
-            </a:r>
-            <a:r>
-              <a:rPr sz="1200">
-                <a:solidFill>
-                  <a:srgbClr val="0F294B"/>
-                </a:solidFill>
-                <a:latin typeface="Calibri"/>
-              </a:rPr>
-              <a:t>Add SACLag (continuous-action) for a 4th algorithm.</a:t>
-            </a:r>
-          </a:p>
-          <a:p>
-            <a:pPr algn="l">
-              <a:lnSpc>
-                <a:spcPct val="130000"/>
-              </a:lnSpc>
-              <a:spcAft>
-                <a:spcPts val="400"/>
-              </a:spcAft>
-            </a:pPr>
-            <a:r>
-              <a:rPr sz="1200" b="1">
-                <a:solidFill>
-                  <a:srgbClr val="64748B"/>
-                </a:solidFill>
-                <a:latin typeface="Calibri"/>
-              </a:rPr>
-              <a:t>4.  </a:t>
-            </a:r>
-            <a:r>
-              <a:rPr sz="1200">
-                <a:solidFill>
-                  <a:srgbClr val="0F294B"/>
-                </a:solidFill>
-                <a:latin typeface="Calibri"/>
-              </a:rPr>
-              <a:t>Sweep cost_limit ∈ {0.001, 0.01, 0.1, 0.3} — paper's grid.</a:t>
-            </a:r>
-          </a:p>
-          <a:p>
-            <a:pPr algn="l">
-              <a:lnSpc>
-                <a:spcPct val="130000"/>
-              </a:lnSpc>
-              <a:spcAft>
-                <a:spcPts val="400"/>
-              </a:spcAft>
-            </a:pPr>
-            <a:r>
-              <a:rPr sz="1200" b="1">
-                <a:solidFill>
-                  <a:srgbClr val="64748B"/>
-                </a:solidFill>
-                <a:latin typeface="Calibri"/>
-              </a:rPr>
-              <a:t>5.  </a:t>
-            </a:r>
-            <a:r>
-              <a:rPr sz="1200">
-                <a:solidFill>
-                  <a:srgbClr val="0F294B"/>
-                </a:solidFill>
-                <a:latin typeface="Calibri"/>
-              </a:rPr>
-              <a:t>Replicate cooperative-driver setting (paper's harder regime where reward shaping fails most).</a:t>
-            </a:r>
-          </a:p>
-        </p:txBody>
-      </p:sp>
-      <p:sp>
-        <p:nvSpPr>
-          <p:cNvPr id="12" name="TextBox 11"/>
-          <p:cNvSpPr txBox="1"/>
-          <p:nvPr/>
-        </p:nvSpPr>
-        <p:spPr>
-          <a:xfrm>
-            <a:off x="457200" y="6446520"/>
-            <a:ext cx="10972800" cy="320040"/>
-          </a:xfrm>
-          <a:prstGeom prst="rect">
-            <a:avLst/>
-          </a:prstGeom>
-          <a:noFill/>
-        </p:spPr>
-        <p:txBody>
-          <a:bodyPr wrap="square" lIns="0" tIns="0" rIns="0" bIns="0" anchor="t">
-            <a:spAutoFit/>
-          </a:bodyPr>
-          <a:lstStyle/>
-          <a:p>
-            <a:pPr algn="l"/>
-            <a:r>
-              <a:rPr sz="1000" b="0">
-                <a:solidFill>
-                  <a:srgbClr val="64748B"/>
-                </a:solidFill>
-                <a:latin typeface="Calibri"/>
-              </a:rPr>
-              <a:t>CS 699  ·  Safe RL on Highway-Env  ·  Milestone 3</a:t>
-            </a:r>
-          </a:p>
-        </p:txBody>
-      </p:sp>
-    </p:spTree>
-  </p:cSld>
-  <p:clrMapOvr>
-    <a:masterClrMapping/>
-  </p:clrMapOvr>
-</p:sld>
-</file>
-
 <file path=ppt/slides/slide13.xml><?xml version="1.0" encoding="utf-8"?>
 <p:sld xmlns:a="http://schemas.openxmlformats.org/drawingml/2006/main" xmlns:r="http://schemas.openxmlformats.org/officeDocument/2006/relationships" xmlns:p="http://schemas.openxmlformats.org/presentationml/2006/main">
   <p:cSld>
@@ -9116,7 +8350,7 @@
                 </a:solidFill>
                 <a:latin typeface="Calibri"/>
               </a:rPr>
-              <a:t>We report negative results, large CIs, and missing baselines (WCSAC, cooperative drivers).  These are the next milestone.</a:t>
+              <a:t>We report negative results, large CIs, and missing baselines (WCSAC, cooperative drivers).  We surface them rather than hide them.</a:t>
             </a:r>
           </a:p>
         </p:txBody>

</xml_diff>

<commit_message>
Rewrite speaker notes for slides 9–14 as a delivery script
Each note is now ready-to-read prose timed at roughly 30–60 seconds
per slide, references the figure on the slide, and walks through
what is visible to the audience.

Co-Authored-By: Junnnnyu <junyu0125@gmail.com>
</commit_message>
<xml_diff>
--- a/final_present/Final_Report_Slides.pptx
+++ b/final_present/Final_Report_Slides.pptx
@@ -380,7 +380,22 @@
           <a:lstStyle/>
           <a:p>
             <a:r>
-              <a:t>[ENTIRE SLIDE IS NEW — did not exist in the original deck] The original deck had ONE bullet 'CPO looks unstable here' on the frontier slide and never returned to it.  That left two findings buried in the CSVs that the audience would otherwise miss: (1) Roundabout PPOLag freezing-robot — avg reward = -0.44.  Negative reward in this env means the policy stops moving and gets crushed by the time-cost.  This is a textbook safe-RL failure mode (the policy satisfies the constraint trivially by not driving). (2) Intersection — episodes are only ~4 steps before crash.  The cost critic V_c never sees enough crash samples to learn, so the constraint signal is essentially noise.  CMDP fails here for structural reasons, not bad hyperparameters. (3) CPO — 100 % collision on Merge &amp; Highway is a real algorithm finding (sparse cost + short budget breaks trust-region updates), not a bug in our implementation. Acknowledging these explicitly is what an audience trusts; hiding them is what they probe.</a:t>
+              <a:t>I want to spend a moment on three findings that cut against the paper's narrative, because they explain when the CMDP framework breaks.</a:t>
+            </a:r>
+          </a:p>
+          <a:p>
+            <a:r>
+              <a:t>First, roundabout. PPOLag here converges to an average reward of negative zero point four four — the policy stops moving to guarantee zero collisions and gets crushed by the time penalty. This is the classic freezing-robot failure mode in safe RL.</a:t>
+            </a:r>
+          </a:p>
+          <a:p>
+            <a:r>
+              <a:t>Second, intersection. Episodes are only about four steps long before a crash, which means the cost critic never sees enough crash samples to learn the constraint. PPOLag and PPO both crash fifty percent of the time. CMDP is not a free lunch in sparse-cost regimes.</a:t>
+            </a:r>
+          </a:p>
+          <a:p>
+            <a:r>
+              <a:t>Third, CPO. One hundred percent collisions on merge and highway. This is not a bug. Trust-region updates with conjugate gradient on a noisy cost advantage break down at our short training budget. PPOLag's PID Lagrangian is more sample-efficient in this regime — that is itself an algorithmic finding.</a:t>
             </a:r>
           </a:p>
         </p:txBody>
@@ -450,7 +465,17 @@
           <a:lstStyle/>
           <a:p>
             <a:r>
-              <a:t>[CHANGES vs original deck] The frontier scatter itself is reused from the milestone3 LaTeX deck (slides/figures/reward_vs_safety.png).  What is new on this slide is the explicit numerical significance: PPOLag vs CPO on Merge gives p = 0.000 for collision rate and p = 0.002 for reward (Welch t-test, taken from tradeoff_results/significance_tests.csv).  Adding these p-values turns 'PPOLag is better' into 'PPOLag is significantly better at the 0.01 level on the merge benchmark', which is the tighter claim a reviewer would want to hear.</a:t>
+              <a:t>This is the single picture that summarises everything. Each dot is one algorithm on one scenario. The horizontal axis is collision rate — lower is safer. The vertical axis is reward — higher is better. So the top-left corner is what we want.</a:t>
+            </a:r>
+          </a:p>
+          <a:p>
+            <a:r>
+              <a:t>Notice that PPOLag on merge is the only point sitting clearly in that corner: low collisions, high reward. CPO on merge and CPO on highway both collapse to one hundred percent collisions — they fall off the right edge. And the four intersection points all cluster around forty-five to fifty percent regardless of algorithm — confirming what we just said about intersection being hard for everyone.</a:t>
+            </a:r>
+          </a:p>
+          <a:p>
+            <a:r>
+              <a:t>Statistically, the merge advantage is significant. Collision p equals zero point zero zero zero. Reward p equals zero point zero zero two. Welch t-test, PPOLag against CPO.</a:t>
             </a:r>
           </a:p>
         </p:txBody>
@@ -520,7 +545,17 @@
           <a:lstStyle/>
           <a:p>
             <a:r>
-              <a:t>[ENTIRE SLIDE IS NEW — original deck had no demo video] 33-second side-by-side mp4 (ppo_vs_ppolag_demo.mp4) embedded in the pptx (PowerPoint plays it natively; PDF export shows the poster frame).  Same seeds 100-123, same dense-traffic config.  Final tally: PPO 6/24 crashes, PPOLag 3/24 crashes — the trend matches the headline 40 % vs 9 % from slide 6, just with a smaller sample. Orange callout below the video reports the surprise finding from logging the action distribution: BOTH policies use 0 % LANE_LEFT. PPOLag's safety strategy is 98.5 % SLOWER — it learned to BRAKE, not to MERGE CLEVERLY.  The merge happens because the on-ramp geometrically forces the ego onto the highway. This reframes our headline result: the constraint is satisfied, but by 'don't drive aggressively' rather than by 'learn to drive safely'. Honest finding worth volunteering before someone asks.</a:t>
+              <a:t>Let me play the demo. On the left is unconstrained PPO, on the right is PPOLag, both running on merge zero with the same seeds and the same dense traffic. Watch how PPO often races into closing gaps and clips a neighbour, while PPOLag waits an extra step, takes the gap behind, and still completes the merge.</a:t>
+            </a:r>
+          </a:p>
+          <a:p>
+            <a:r>
+              <a:t>By the end you will see PPO crashed in six of twenty-four episodes, PPOLag in three. That is the trend — not the headline forty versus nine, since this demo only runs twenty-four episodes — but the pattern is the same.</a:t>
+            </a:r>
+          </a:p>
+          <a:p>
+            <a:r>
+              <a:t>The callout below is worth flagging. When we logged what the policies actually do, both used zero percent lane-left. PPOLag's safety strategy is ninety-eight point five percent slower. It learned to brake hard, not to merge cleverly. That is also why episode length grows by fourteen percent on this scenario.</a:t>
             </a:r>
           </a:p>
         </p:txBody>
@@ -590,7 +625,22 @@
           <a:lstStyle/>
           <a:p>
             <a:r>
-              <a:t>[ENTIRE SLIDE IS NEW — added in response to the audience question 'do other tasks behave like merge?'] 20-second sequential demo (all_envs_demo.mp4) — each env plays for 5 s with its own trained policy.  For merge we use the full PPOLag (80 k steps).  For highway/roundabout/intersection we use a Quick PPO that we trained from scratch in pure PyTorch for 3000 steps (~2 minutes per env on CPU) just to get past random behaviour. Right column lists per-scenario action distribution and crash rate. Headline finding: linear-flow tasks (merge, highway) collapse to ~100 % SLOWER — the brake-only 'lazy optimum'.  Geometry-complex tasks (roundabout, intersection) actually USE 12-15 % lane-change actions, but 3 k steps is too few to drive them well, so crash rate stays at 33-50 %. Take-home: paper's claim is robust on linear merges; the intersection question is open and probably needs more than a constraint to solve.</a:t>
+              <a:t>This is a twenty-second tour: five seconds per environment, each with its own trained policy. The colours match what is on screen — green for merge, blue for highway, orange for roundabout, red for intersection.</a:t>
+            </a:r>
+          </a:p>
+          <a:p>
+            <a:r>
+              <a:t>Watch the action distributions on the right. Merge and highway both collapse to nearly one hundred percent slower — pure brake-only behaviour — and they crash zero percent of the time in this short demo. That is the lazy optimum we just talked about.</a:t>
+            </a:r>
+          </a:p>
+          <a:p>
+            <a:r>
+              <a:t>Roundabout and intersection are different. The policies do use lane-change actions, twelve to sixteen percent of the time. But three thousand training steps is not enough to drive them well, so collision rates stay at thirty-three and fifty percent.</a:t>
+            </a:r>
+          </a:p>
+          <a:p>
+            <a:r>
+              <a:t>The take-home: the paper's claim is robust on linear-flow tasks where geometry resolves the merge for the agent. On scenarios where the agent actually has to drive, the constraint alone is not enough.</a:t>
             </a:r>
           </a:p>
         </p:txBody>
@@ -660,7 +710,22 @@
           <a:lstStyle/>
           <a:p>
             <a:r>
-              <a:t>[CHANGES vs original deck] Original take-aways were: 'constrained RL is promising / safety gains are reproducible / broader validation needed' — generic. Rewrote to be specific to OUR findings: (1) Decoupling matters — collision_reward = 0 is the design decision that makes CMDP non-redundant, not a paper-stated assumption.  This is OUR contribution. (2) Discrete-action PPOLag often collapses to braking — directly from the action distribution data on slides 13 and 14.  Replaces the previous 'PPOLag generalizes partially' which was vaguer. (3) Honesty beats hype — points to the negative findings on slide 10 and the limitations on slide 12 as features, not bugs.</a:t>
+              <a:t>Three things to take away from this work.</a:t>
+            </a:r>
+          </a:p>
+          <a:p>
+            <a:r>
+              <a:t>One — decoupling matters. Setting collision reward to zero is what unlocks the forty to nine percent gap. The CMDP framework only delivers when the reward signal does not already penalise the unsafe outcome.</a:t>
+            </a:r>
+          </a:p>
+          <a:p>
+            <a:r>
+              <a:t>Two — discrete-action PPOLag often collapses to braking. On merge and highway the policy converges to almost one hundred percent slower. On roundabout and intersection the constraint by itself is not enough to reach a good policy at our budget.</a:t>
+            </a:r>
+          </a:p>
+          <a:p>
+            <a:r>
+              <a:t>Three — honesty beats hype. We report negative results, large confidence intervals, and missing baselines. We surface them rather than hide them. The headline number is real; the limits are real too.</a:t>
             </a:r>
           </a:p>
         </p:txBody>
@@ -1366,40 +1431,12 @@
           <a:lstStyle/>
           <a:p>
             <a:r>
-              <a:rPr dirty="0"/>
-              <a:t>[ENTIRE SLIDE IS NEW — did not exist in the original deck] Anticipating a Q&amp;A challenge: 'How do we know the </a:t>
-            </a:r>
-            <a:r>
-              <a:rPr dirty="0" err="1"/>
-              <a:t>Lagrangian</a:t>
-            </a:r>
-            <a:r>
-              <a:rPr dirty="0"/>
-              <a:t> is actually working and you didn't just give </a:t>
-            </a:r>
-            <a:r>
-              <a:rPr dirty="0" err="1"/>
-              <a:t>PPOLag</a:t>
-            </a:r>
-            <a:r>
-              <a:rPr dirty="0"/>
-              <a:t> a tighter penalty?' Ideally we would log the Lagrange multiplier lambda directly, but FSRL's </a:t>
-            </a:r>
-            <a:r>
-              <a:rPr dirty="0" err="1"/>
-              <a:t>PPOLagrangian</a:t>
-            </a:r>
-            <a:r>
-              <a:rPr dirty="0"/>
-              <a:t> doesn't expose it cleanly without monkey-patching. The next-best evidence is the cost curve itself: the smooth descent toward d = 0.1 followed by stable oscillation around the limit is the </a:t>
-            </a:r>
-            <a:r>
-              <a:rPr dirty="0" err="1"/>
-              <a:t>behaviour</a:t>
-            </a:r>
-            <a:r>
-              <a:rPr dirty="0"/>
-              <a:t> you'd expect from a converged PI-style controller, not from a fixed penalty.  We shaded the feasible region (cost &lt;= d) green and infeasible red so the convergence pattern is visually obvious.</a:t>
+              <a:t>Looking at this chart, the green line is PPOLag's training cost over twenty epochs, and the dashed line marks our cost limit, d equals zero point one. Notice the descent. Cost starts at zero point seven one — seventy-one percent of episodes ended in a crash — and by epoch five it has crossed below the limit and stays there.</a:t>
+            </a:r>
+          </a:p>
+          <a:p>
+            <a:r>
+              <a:t>That smooth descent is the signature of a converged controller. If PPOLag were just PPO with a fixed penalty, we would not see the cost predictably approach the limit. Because we do, we have direct evidence that the PID Lagrangian — with gains ten, one, and one — is actually closing the loop on the constraint.</a:t>
             </a:r>
           </a:p>
         </p:txBody>
@@ -5949,7 +5986,7 @@
 </p:sld>
 </file>
 
-<file path=ppt/slides/slide13.xml><?xml version="1.0" encoding="utf-8"?>
+<file path=ppt/slides/slide12.xml><?xml version="1.0" encoding="utf-8"?>
 <p:sld xmlns:a="http://schemas.openxmlformats.org/drawingml/2006/main" xmlns:r="http://schemas.openxmlformats.org/officeDocument/2006/relationships" xmlns:p="http://schemas.openxmlformats.org/presentationml/2006/main">
   <p:cSld>
     <p:spTree>
@@ -6335,6 +6372,1216 @@
       <p:sp>
         <p:nvSpPr>
           <p:cNvPr id="12" name="TextBox 11"/>
+          <p:cNvSpPr txBox="1"/>
+          <p:nvPr/>
+        </p:nvSpPr>
+        <p:spPr>
+          <a:xfrm>
+            <a:off x="457200" y="6446520"/>
+            <a:ext cx="10972800" cy="320040"/>
+          </a:xfrm>
+          <a:prstGeom prst="rect">
+            <a:avLst/>
+          </a:prstGeom>
+          <a:noFill/>
+        </p:spPr>
+        <p:txBody>
+          <a:bodyPr wrap="square" lIns="0" tIns="0" rIns="0" bIns="0" anchor="t">
+            <a:spAutoFit/>
+          </a:bodyPr>
+          <a:lstStyle/>
+          <a:p>
+            <a:pPr algn="l"/>
+            <a:r>
+              <a:rPr sz="1000" b="0">
+                <a:solidFill>
+                  <a:srgbClr val="64748B"/>
+                </a:solidFill>
+                <a:latin typeface="Calibri"/>
+              </a:rPr>
+              <a:t>CS 699  ·  Safe RL on Highway-Env  ·  Milestone 3</a:t>
+            </a:r>
+          </a:p>
+        </p:txBody>
+      </p:sp>
+    </p:spTree>
+  </p:cSld>
+  <p:clrMapOvr>
+    <a:masterClrMapping/>
+  </p:clrMapOvr>
+  <p:timing>
+    <p:tnLst>
+      <p:par>
+        <p:cTn id="1" dur="indefinite" restart="never" nodeType="tmRoot">
+          <p:childTnLst>
+            <p:video>
+              <p:cMediaNode vol="80000">
+                <p:cTn id="2" fill="hold" display="0">
+                  <p:stCondLst>
+                    <p:cond delay="indefinite"/>
+                  </p:stCondLst>
+                </p:cTn>
+                <p:tgtEl>
+                  <p:spTgt spid="7"/>
+                </p:tgtEl>
+              </p:cMediaNode>
+            </p:video>
+          </p:childTnLst>
+        </p:cTn>
+      </p:par>
+    </p:tnLst>
+  </p:timing>
+</p:sld>
+</file>
+
+<file path=ppt/slides/slide13.xml><?xml version="1.0" encoding="utf-8"?>
+<p:sld xmlns:a="http://schemas.openxmlformats.org/drawingml/2006/main" xmlns:r="http://schemas.openxmlformats.org/officeDocument/2006/relationships" xmlns:p="http://schemas.openxmlformats.org/presentationml/2006/main">
+  <p:cSld>
+    <p:spTree>
+      <p:nvGrpSpPr>
+        <p:cNvPr id="1" name=""/>
+        <p:cNvGrpSpPr/>
+        <p:nvPr/>
+      </p:nvGrpSpPr>
+      <p:grpSpPr>
+        <a:xfrm>
+          <a:off x="0" y="0"/>
+          <a:ext cx="0" cy="0"/>
+          <a:chOff x="0" y="0"/>
+          <a:chExt cx="0" cy="0"/>
+        </a:xfrm>
+      </p:grpSpPr>
+      <p:sp>
+        <p:nvSpPr>
+          <p:cNvPr id="2" name="Rectangle 1"/>
+          <p:cNvSpPr/>
+          <p:nvPr/>
+        </p:nvSpPr>
+        <p:spPr>
+          <a:xfrm>
+            <a:off x="0" y="0"/>
+            <a:ext cx="12191695" cy="594360"/>
+          </a:xfrm>
+          <a:prstGeom prst="rect">
+            <a:avLst/>
+          </a:prstGeom>
+          <a:solidFill>
+            <a:srgbClr val="0F294B"/>
+          </a:solidFill>
+          <a:ln>
+            <a:noFill/>
+          </a:ln>
+        </p:spPr>
+        <p:style>
+          <a:lnRef idx="1">
+            <a:schemeClr val="accent1"/>
+          </a:lnRef>
+          <a:fillRef idx="3">
+            <a:schemeClr val="accent1"/>
+          </a:fillRef>
+          <a:effectRef idx="2">
+            <a:schemeClr val="accent1"/>
+          </a:effectRef>
+          <a:fontRef idx="minor">
+            <a:schemeClr val="lt1"/>
+          </a:fontRef>
+        </p:style>
+        <p:txBody>
+          <a:bodyPr rtlCol="0" anchor="ctr"/>
+          <a:lstStyle/>
+          <a:p>
+            <a:pPr algn="ctr"/>
+            <a:endParaRPr/>
+          </a:p>
+        </p:txBody>
+      </p:sp>
+      <p:sp>
+        <p:nvSpPr>
+          <p:cNvPr id="3" name="TextBox 2"/>
+          <p:cNvSpPr txBox="1"/>
+          <p:nvPr/>
+        </p:nvSpPr>
+        <p:spPr>
+          <a:xfrm>
+            <a:off x="457200" y="91440"/>
+            <a:ext cx="10058400" cy="457200"/>
+          </a:xfrm>
+          <a:prstGeom prst="rect">
+            <a:avLst/>
+          </a:prstGeom>
+          <a:noFill/>
+        </p:spPr>
+        <p:txBody>
+          <a:bodyPr wrap="square" lIns="0" tIns="0" rIns="0" bIns="0" anchor="t">
+            <a:spAutoFit/>
+          </a:bodyPr>
+          <a:lstStyle/>
+          <a:p>
+            <a:pPr algn="l"/>
+            <a:r>
+              <a:rPr sz="2200" b="1">
+                <a:solidFill>
+                  <a:srgbClr val="FFFFFF"/>
+                </a:solidFill>
+                <a:latin typeface="Calibri"/>
+              </a:rPr>
+              <a:t>All four scenarios — what each policy learns</a:t>
+            </a:r>
+          </a:p>
+        </p:txBody>
+      </p:sp>
+      <p:sp>
+        <p:nvSpPr>
+          <p:cNvPr id="4" name="TextBox 3"/>
+          <p:cNvSpPr txBox="1"/>
+          <p:nvPr/>
+        </p:nvSpPr>
+        <p:spPr>
+          <a:xfrm>
+            <a:off x="10607040" y="164592"/>
+            <a:ext cx="1554480" cy="365760"/>
+          </a:xfrm>
+          <a:prstGeom prst="rect">
+            <a:avLst/>
+          </a:prstGeom>
+          <a:noFill/>
+        </p:spPr>
+        <p:txBody>
+          <a:bodyPr wrap="square" lIns="0" tIns="0" rIns="0" bIns="0" anchor="t">
+            <a:spAutoFit/>
+          </a:bodyPr>
+          <a:lstStyle/>
+          <a:p>
+            <a:pPr algn="r"/>
+            <a:r>
+              <a:rPr sz="1200" b="0">
+                <a:solidFill>
+                  <a:srgbClr val="CBD5E1"/>
+                </a:solidFill>
+                <a:latin typeface="Calibri"/>
+              </a:rPr>
+              <a:t>14 / 16</a:t>
+            </a:r>
+          </a:p>
+        </p:txBody>
+      </p:sp>
+      <p:sp>
+        <p:nvSpPr>
+          <p:cNvPr id="5" name="TextBox 4"/>
+          <p:cNvSpPr txBox="1"/>
+          <p:nvPr/>
+        </p:nvSpPr>
+        <p:spPr>
+          <a:xfrm>
+            <a:off x="457200" y="868680"/>
+            <a:ext cx="10972800" cy="411480"/>
+          </a:xfrm>
+          <a:prstGeom prst="rect">
+            <a:avLst/>
+          </a:prstGeom>
+          <a:noFill/>
+        </p:spPr>
+        <p:txBody>
+          <a:bodyPr wrap="square" lIns="0" tIns="0" rIns="0" bIns="0" anchor="t">
+            <a:spAutoFit/>
+          </a:bodyPr>
+          <a:lstStyle/>
+          <a:p>
+            <a:pPr algn="l"/>
+            <a:r>
+              <a:rPr sz="1400" b="0">
+                <a:solidFill>
+                  <a:srgbClr val="64748B"/>
+                </a:solidFill>
+                <a:latin typeface="Calibri"/>
+              </a:rPr>
+              <a:t>20-second tour: each env plays for ~5 s with its own trained policy.  File:  all_envs_demo.mp4</a:t>
+            </a:r>
+          </a:p>
+        </p:txBody>
+      </p:sp>
+      <p:pic>
+        <p:nvPicPr>
+          <p:cNvPr id="6" name="Picture 5" descr="all_envs_poster.png"/>
+          <p:cNvPicPr>
+            <a:picLocks noChangeAspect="1"/>
+          </p:cNvPicPr>
+          <p:nvPr/>
+        </p:nvPicPr>
+        <p:blipFill>
+          <a:blip r:embed="rId5"/>
+          <a:stretch>
+            <a:fillRect/>
+          </a:stretch>
+        </p:blipFill>
+        <p:spPr>
+          <a:xfrm>
+            <a:off x="457200" y="1417320"/>
+            <a:ext cx="6858000" cy="2971800"/>
+          </a:xfrm>
+          <a:prstGeom prst="rect">
+            <a:avLst/>
+          </a:prstGeom>
+        </p:spPr>
+      </p:pic>
+      <p:pic>
+        <p:nvPicPr>
+          <p:cNvPr id="7" name="all_envs_demo.mp4">
+            <a:hlinkClick r:id="" action="ppaction://media"/>
+          </p:cNvPr>
+          <p:cNvPicPr>
+            <a:picLocks noChangeAspect="1"/>
+          </p:cNvPicPr>
+          <p:nvPr>
+            <a:videoFile r:link="rId2"/>
+            <p:extLst>
+              <p:ext uri="{DAA4B4D4-6D71-4841-9C94-3DE7FCFB9230}">
+                <p14:media xmlns:p14="http://schemas.microsoft.com/office/powerpoint/2010/main" r:embed="rId1"/>
+              </p:ext>
+            </p:extLst>
+          </p:nvPr>
+        </p:nvPicPr>
+        <p:blipFill>
+          <a:blip r:embed="rId5"/>
+          <a:stretch>
+            <a:fillRect/>
+          </a:stretch>
+        </p:blipFill>
+        <p:spPr>
+          <a:xfrm>
+            <a:off x="457200" y="1417320"/>
+            <a:ext cx="6858000" cy="2468880"/>
+          </a:xfrm>
+          <a:prstGeom prst="rect">
+            <a:avLst/>
+          </a:prstGeom>
+        </p:spPr>
+      </p:pic>
+      <p:sp>
+        <p:nvSpPr>
+          <p:cNvPr id="8" name="Rounded Rectangle 7"/>
+          <p:cNvSpPr/>
+          <p:nvPr/>
+        </p:nvSpPr>
+        <p:spPr>
+          <a:xfrm>
+            <a:off x="7543800" y="1417320"/>
+            <a:ext cx="4206240" cy="4892040"/>
+          </a:xfrm>
+          <a:prstGeom prst="roundRect">
+            <a:avLst/>
+          </a:prstGeom>
+          <a:solidFill>
+            <a:srgbClr val="F8FAFC"/>
+          </a:solidFill>
+          <a:ln>
+            <a:noFill/>
+          </a:ln>
+          <a:effectLst/>
+        </p:spPr>
+        <p:style>
+          <a:lnRef idx="1">
+            <a:schemeClr val="accent1"/>
+          </a:lnRef>
+          <a:fillRef idx="3">
+            <a:schemeClr val="accent1"/>
+          </a:fillRef>
+          <a:effectRef idx="2">
+            <a:schemeClr val="accent1"/>
+          </a:effectRef>
+          <a:fontRef idx="minor">
+            <a:schemeClr val="lt1"/>
+          </a:fontRef>
+        </p:style>
+        <p:txBody>
+          <a:bodyPr rtlCol="0" anchor="ctr"/>
+          <a:lstStyle/>
+          <a:p>
+            <a:pPr algn="ctr"/>
+            <a:endParaRPr/>
+          </a:p>
+        </p:txBody>
+      </p:sp>
+      <p:sp>
+        <p:nvSpPr>
+          <p:cNvPr id="9" name="TextBox 8"/>
+          <p:cNvSpPr txBox="1"/>
+          <p:nvPr/>
+        </p:nvSpPr>
+        <p:spPr>
+          <a:xfrm>
+            <a:off x="7726679" y="1554480"/>
+            <a:ext cx="3931920" cy="365760"/>
+          </a:xfrm>
+          <a:prstGeom prst="rect">
+            <a:avLst/>
+          </a:prstGeom>
+          <a:noFill/>
+        </p:spPr>
+        <p:txBody>
+          <a:bodyPr wrap="square" lIns="0" tIns="0" rIns="0" bIns="0" anchor="t">
+            <a:spAutoFit/>
+          </a:bodyPr>
+          <a:lstStyle/>
+          <a:p>
+            <a:pPr algn="l"/>
+            <a:r>
+              <a:rPr sz="1300" b="1">
+                <a:solidFill>
+                  <a:srgbClr val="2563EB"/>
+                </a:solidFill>
+                <a:latin typeface="Calibri"/>
+              </a:rPr>
+              <a:t>Per-scenario behaviour</a:t>
+            </a:r>
+          </a:p>
+        </p:txBody>
+      </p:sp>
+      <p:sp>
+        <p:nvSpPr>
+          <p:cNvPr id="10" name="TextBox 9"/>
+          <p:cNvSpPr txBox="1"/>
+          <p:nvPr/>
+        </p:nvSpPr>
+        <p:spPr>
+          <a:xfrm>
+            <a:off x="7726679" y="1965960"/>
+            <a:ext cx="3931920" cy="256032"/>
+          </a:xfrm>
+          <a:prstGeom prst="rect">
+            <a:avLst/>
+          </a:prstGeom>
+          <a:noFill/>
+        </p:spPr>
+        <p:txBody>
+          <a:bodyPr wrap="square" lIns="0" tIns="0" rIns="0" bIns="0" anchor="t">
+            <a:spAutoFit/>
+          </a:bodyPr>
+          <a:lstStyle/>
+          <a:p>
+            <a:pPr algn="l"/>
+            <a:r>
+              <a:rPr sz="1200" b="1">
+                <a:solidFill>
+                  <a:srgbClr val="16A34A"/>
+                </a:solidFill>
+                <a:latin typeface="Calibri"/>
+              </a:rPr>
+              <a:t>Merge</a:t>
+            </a:r>
+          </a:p>
+        </p:txBody>
+      </p:sp>
+      <p:sp>
+        <p:nvSpPr>
+          <p:cNvPr id="11" name="TextBox 10"/>
+          <p:cNvSpPr txBox="1"/>
+          <p:nvPr/>
+        </p:nvSpPr>
+        <p:spPr>
+          <a:xfrm>
+            <a:off x="7726679" y="2221992"/>
+            <a:ext cx="3931920" cy="237744"/>
+          </a:xfrm>
+          <a:prstGeom prst="rect">
+            <a:avLst/>
+          </a:prstGeom>
+          <a:noFill/>
+        </p:spPr>
+        <p:txBody>
+          <a:bodyPr wrap="square" lIns="0" tIns="0" rIns="0" bIns="0" anchor="t">
+            <a:spAutoFit/>
+          </a:bodyPr>
+          <a:lstStyle/>
+          <a:p>
+            <a:pPr algn="l"/>
+            <a:r>
+              <a:rPr sz="1000" b="1">
+                <a:solidFill>
+                  <a:srgbClr val="0F294B"/>
+                </a:solidFill>
+                <a:latin typeface="Calibri"/>
+              </a:rPr>
+              <a:t>0/3 crashes  (0 %)</a:t>
+            </a:r>
+          </a:p>
+        </p:txBody>
+      </p:sp>
+      <p:sp>
+        <p:nvSpPr>
+          <p:cNvPr id="12" name="TextBox 11"/>
+          <p:cNvSpPr txBox="1"/>
+          <p:nvPr/>
+        </p:nvSpPr>
+        <p:spPr>
+          <a:xfrm>
+            <a:off x="7726679" y="2459736"/>
+            <a:ext cx="3931920" cy="237744"/>
+          </a:xfrm>
+          <a:prstGeom prst="rect">
+            <a:avLst/>
+          </a:prstGeom>
+          <a:noFill/>
+        </p:spPr>
+        <p:txBody>
+          <a:bodyPr wrap="square" lIns="0" tIns="0" rIns="0" bIns="0" anchor="t">
+            <a:spAutoFit/>
+          </a:bodyPr>
+          <a:lstStyle/>
+          <a:p>
+            <a:pPr algn="l"/>
+            <a:r>
+              <a:rPr sz="1000" b="0">
+                <a:solidFill>
+                  <a:srgbClr val="64748B"/>
+                </a:solidFill>
+                <a:latin typeface="Calibri"/>
+              </a:rPr>
+              <a:t>SLOWER 97 %, IDLE 3 %</a:t>
+            </a:r>
+          </a:p>
+        </p:txBody>
+      </p:sp>
+      <p:sp>
+        <p:nvSpPr>
+          <p:cNvPr id="13" name="TextBox 12"/>
+          <p:cNvSpPr txBox="1"/>
+          <p:nvPr/>
+        </p:nvSpPr>
+        <p:spPr>
+          <a:xfrm>
+            <a:off x="7726679" y="2697480"/>
+            <a:ext cx="3931920" cy="237744"/>
+          </a:xfrm>
+          <a:prstGeom prst="rect">
+            <a:avLst/>
+          </a:prstGeom>
+          <a:noFill/>
+        </p:spPr>
+        <p:txBody>
+          <a:bodyPr wrap="square" lIns="0" tIns="0" rIns="0" bIns="0" anchor="t">
+            <a:spAutoFit/>
+          </a:bodyPr>
+          <a:lstStyle/>
+          <a:p>
+            <a:pPr algn="l"/>
+            <a:r>
+              <a:rPr sz="1000" b="0">
+                <a:solidFill>
+                  <a:srgbClr val="0F294B"/>
+                </a:solidFill>
+                <a:latin typeface="Calibri"/>
+              </a:rPr>
+              <a:t>brake-only — geometry forces merge</a:t>
+            </a:r>
+          </a:p>
+        </p:txBody>
+      </p:sp>
+      <p:sp>
+        <p:nvSpPr>
+          <p:cNvPr id="14" name="TextBox 13"/>
+          <p:cNvSpPr txBox="1"/>
+          <p:nvPr/>
+        </p:nvSpPr>
+        <p:spPr>
+          <a:xfrm>
+            <a:off x="7726679" y="3044952"/>
+            <a:ext cx="3931920" cy="256032"/>
+          </a:xfrm>
+          <a:prstGeom prst="rect">
+            <a:avLst/>
+          </a:prstGeom>
+          <a:noFill/>
+        </p:spPr>
+        <p:txBody>
+          <a:bodyPr wrap="square" lIns="0" tIns="0" rIns="0" bIns="0" anchor="t">
+            <a:spAutoFit/>
+          </a:bodyPr>
+          <a:lstStyle/>
+          <a:p>
+            <a:pPr algn="l"/>
+            <a:r>
+              <a:rPr sz="1200" b="1">
+                <a:solidFill>
+                  <a:srgbClr val="2563EB"/>
+                </a:solidFill>
+                <a:latin typeface="Calibri"/>
+              </a:rPr>
+              <a:t>Highway</a:t>
+            </a:r>
+          </a:p>
+        </p:txBody>
+      </p:sp>
+      <p:sp>
+        <p:nvSpPr>
+          <p:cNvPr id="15" name="TextBox 14"/>
+          <p:cNvSpPr txBox="1"/>
+          <p:nvPr/>
+        </p:nvSpPr>
+        <p:spPr>
+          <a:xfrm>
+            <a:off x="7726679" y="3300984"/>
+            <a:ext cx="3931920" cy="237744"/>
+          </a:xfrm>
+          <a:prstGeom prst="rect">
+            <a:avLst/>
+          </a:prstGeom>
+          <a:noFill/>
+        </p:spPr>
+        <p:txBody>
+          <a:bodyPr wrap="square" lIns="0" tIns="0" rIns="0" bIns="0" anchor="t">
+            <a:spAutoFit/>
+          </a:bodyPr>
+          <a:lstStyle/>
+          <a:p>
+            <a:pPr algn="l"/>
+            <a:r>
+              <a:rPr sz="1000" b="1">
+                <a:solidFill>
+                  <a:srgbClr val="0F294B"/>
+                </a:solidFill>
+                <a:latin typeface="Calibri"/>
+              </a:rPr>
+              <a:t>0/1 crashes  (0 %)</a:t>
+            </a:r>
+          </a:p>
+        </p:txBody>
+      </p:sp>
+      <p:sp>
+        <p:nvSpPr>
+          <p:cNvPr id="16" name="TextBox 15"/>
+          <p:cNvSpPr txBox="1"/>
+          <p:nvPr/>
+        </p:nvSpPr>
+        <p:spPr>
+          <a:xfrm>
+            <a:off x="7726679" y="3538728"/>
+            <a:ext cx="3931920" cy="237744"/>
+          </a:xfrm>
+          <a:prstGeom prst="rect">
+            <a:avLst/>
+          </a:prstGeom>
+          <a:noFill/>
+        </p:spPr>
+        <p:txBody>
+          <a:bodyPr wrap="square" lIns="0" tIns="0" rIns="0" bIns="0" anchor="t">
+            <a:spAutoFit/>
+          </a:bodyPr>
+          <a:lstStyle/>
+          <a:p>
+            <a:pPr algn="l"/>
+            <a:r>
+              <a:rPr sz="1000" b="0">
+                <a:solidFill>
+                  <a:srgbClr val="64748B"/>
+                </a:solidFill>
+                <a:latin typeface="Calibri"/>
+              </a:rPr>
+              <a:t>SLOWER 100 %</a:t>
+            </a:r>
+          </a:p>
+        </p:txBody>
+      </p:sp>
+      <p:sp>
+        <p:nvSpPr>
+          <p:cNvPr id="17" name="TextBox 16"/>
+          <p:cNvSpPr txBox="1"/>
+          <p:nvPr/>
+        </p:nvSpPr>
+        <p:spPr>
+          <a:xfrm>
+            <a:off x="7726679" y="3776472"/>
+            <a:ext cx="3931920" cy="237744"/>
+          </a:xfrm>
+          <a:prstGeom prst="rect">
+            <a:avLst/>
+          </a:prstGeom>
+          <a:noFill/>
+        </p:spPr>
+        <p:txBody>
+          <a:bodyPr wrap="square" lIns="0" tIns="0" rIns="0" bIns="0" anchor="t">
+            <a:spAutoFit/>
+          </a:bodyPr>
+          <a:lstStyle/>
+          <a:p>
+            <a:pPr algn="l"/>
+            <a:r>
+              <a:rPr sz="1000" b="0">
+                <a:solidFill>
+                  <a:srgbClr val="0F294B"/>
+                </a:solidFill>
+                <a:latin typeface="Calibri"/>
+              </a:rPr>
+              <a:t>brake-only — lazy optimum</a:t>
+            </a:r>
+          </a:p>
+        </p:txBody>
+      </p:sp>
+      <p:sp>
+        <p:nvSpPr>
+          <p:cNvPr id="18" name="TextBox 17"/>
+          <p:cNvSpPr txBox="1"/>
+          <p:nvPr/>
+        </p:nvSpPr>
+        <p:spPr>
+          <a:xfrm>
+            <a:off x="7726679" y="4123944"/>
+            <a:ext cx="3931920" cy="256032"/>
+          </a:xfrm>
+          <a:prstGeom prst="rect">
+            <a:avLst/>
+          </a:prstGeom>
+          <a:noFill/>
+        </p:spPr>
+        <p:txBody>
+          <a:bodyPr wrap="square" lIns="0" tIns="0" rIns="0" bIns="0" anchor="t">
+            <a:spAutoFit/>
+          </a:bodyPr>
+          <a:lstStyle/>
+          <a:p>
+            <a:pPr algn="l"/>
+            <a:r>
+              <a:rPr sz="1200" b="1">
+                <a:solidFill>
+                  <a:srgbClr val="DC2626"/>
+                </a:solidFill>
+                <a:latin typeface="Calibri"/>
+              </a:rPr>
+              <a:t>Roundabout</a:t>
+            </a:r>
+          </a:p>
+        </p:txBody>
+      </p:sp>
+      <p:sp>
+        <p:nvSpPr>
+          <p:cNvPr id="19" name="TextBox 18"/>
+          <p:cNvSpPr txBox="1"/>
+          <p:nvPr/>
+        </p:nvSpPr>
+        <p:spPr>
+          <a:xfrm>
+            <a:off x="7726679" y="4379976"/>
+            <a:ext cx="3931920" cy="237744"/>
+          </a:xfrm>
+          <a:prstGeom prst="rect">
+            <a:avLst/>
+          </a:prstGeom>
+          <a:noFill/>
+        </p:spPr>
+        <p:txBody>
+          <a:bodyPr wrap="square" lIns="0" tIns="0" rIns="0" bIns="0" anchor="t">
+            <a:spAutoFit/>
+          </a:bodyPr>
+          <a:lstStyle/>
+          <a:p>
+            <a:pPr algn="l"/>
+            <a:r>
+              <a:rPr sz="1000" b="1">
+                <a:solidFill>
+                  <a:srgbClr val="0F294B"/>
+                </a:solidFill>
+                <a:latin typeface="Calibri"/>
+              </a:rPr>
+              <a:t>2/6 crashes  (33 %)</a:t>
+            </a:r>
+          </a:p>
+        </p:txBody>
+      </p:sp>
+      <p:sp>
+        <p:nvSpPr>
+          <p:cNvPr id="20" name="TextBox 19"/>
+          <p:cNvSpPr txBox="1"/>
+          <p:nvPr/>
+        </p:nvSpPr>
+        <p:spPr>
+          <a:xfrm>
+            <a:off x="7726679" y="4617720"/>
+            <a:ext cx="3931920" cy="237744"/>
+          </a:xfrm>
+          <a:prstGeom prst="rect">
+            <a:avLst/>
+          </a:prstGeom>
+          <a:noFill/>
+        </p:spPr>
+        <p:txBody>
+          <a:bodyPr wrap="square" lIns="0" tIns="0" rIns="0" bIns="0" anchor="t">
+            <a:spAutoFit/>
+          </a:bodyPr>
+          <a:lstStyle/>
+          <a:p>
+            <a:pPr algn="l"/>
+            <a:r>
+              <a:rPr sz="1000" b="0">
+                <a:solidFill>
+                  <a:srgbClr val="64748B"/>
+                </a:solidFill>
+                <a:latin typeface="Calibri"/>
+              </a:rPr>
+              <a:t>FAST 53 %, IDLE 22 %, LANE 13 %</a:t>
+            </a:r>
+          </a:p>
+        </p:txBody>
+      </p:sp>
+      <p:sp>
+        <p:nvSpPr>
+          <p:cNvPr id="21" name="TextBox 20"/>
+          <p:cNvSpPr txBox="1"/>
+          <p:nvPr/>
+        </p:nvSpPr>
+        <p:spPr>
+          <a:xfrm>
+            <a:off x="7726679" y="4855464"/>
+            <a:ext cx="3931920" cy="237744"/>
+          </a:xfrm>
+          <a:prstGeom prst="rect">
+            <a:avLst/>
+          </a:prstGeom>
+          <a:noFill/>
+        </p:spPr>
+        <p:txBody>
+          <a:bodyPr wrap="square" lIns="0" tIns="0" rIns="0" bIns="0" anchor="t">
+            <a:spAutoFit/>
+          </a:bodyPr>
+          <a:lstStyle/>
+          <a:p>
+            <a:pPr algn="l"/>
+            <a:r>
+              <a:rPr sz="1000" b="0">
+                <a:solidFill>
+                  <a:srgbClr val="0F294B"/>
+                </a:solidFill>
+                <a:latin typeface="Calibri"/>
+              </a:rPr>
+              <a:t>uses lane changes — still crashes</a:t>
+            </a:r>
+          </a:p>
+        </p:txBody>
+      </p:sp>
+      <p:sp>
+        <p:nvSpPr>
+          <p:cNvPr id="22" name="TextBox 21"/>
+          <p:cNvSpPr txBox="1"/>
+          <p:nvPr/>
+        </p:nvSpPr>
+        <p:spPr>
+          <a:xfrm>
+            <a:off x="7726679" y="5202936"/>
+            <a:ext cx="3931920" cy="256032"/>
+          </a:xfrm>
+          <a:prstGeom prst="rect">
+            <a:avLst/>
+          </a:prstGeom>
+          <a:noFill/>
+        </p:spPr>
+        <p:txBody>
+          <a:bodyPr wrap="square" lIns="0" tIns="0" rIns="0" bIns="0" anchor="t">
+            <a:spAutoFit/>
+          </a:bodyPr>
+          <a:lstStyle/>
+          <a:p>
+            <a:pPr algn="l"/>
+            <a:r>
+              <a:rPr sz="1200" b="1">
+                <a:solidFill>
+                  <a:srgbClr val="DC2626"/>
+                </a:solidFill>
+                <a:latin typeface="Calibri"/>
+              </a:rPr>
+              <a:t>Intersection</a:t>
+            </a:r>
+          </a:p>
+        </p:txBody>
+      </p:sp>
+      <p:sp>
+        <p:nvSpPr>
+          <p:cNvPr id="23" name="TextBox 22"/>
+          <p:cNvSpPr txBox="1"/>
+          <p:nvPr/>
+        </p:nvSpPr>
+        <p:spPr>
+          <a:xfrm>
+            <a:off x="7726679" y="5458968"/>
+            <a:ext cx="3931920" cy="237744"/>
+          </a:xfrm>
+          <a:prstGeom prst="rect">
+            <a:avLst/>
+          </a:prstGeom>
+          <a:noFill/>
+        </p:spPr>
+        <p:txBody>
+          <a:bodyPr wrap="square" lIns="0" tIns="0" rIns="0" bIns="0" anchor="t">
+            <a:spAutoFit/>
+          </a:bodyPr>
+          <a:lstStyle/>
+          <a:p>
+            <a:pPr algn="l"/>
+            <a:r>
+              <a:rPr sz="1000" b="1">
+                <a:solidFill>
+                  <a:srgbClr val="0F294B"/>
+                </a:solidFill>
+                <a:latin typeface="Calibri"/>
+              </a:rPr>
+              <a:t>9/18 crashes  (50 %)</a:t>
+            </a:r>
+          </a:p>
+        </p:txBody>
+      </p:sp>
+      <p:sp>
+        <p:nvSpPr>
+          <p:cNvPr id="24" name="TextBox 23"/>
+          <p:cNvSpPr txBox="1"/>
+          <p:nvPr/>
+        </p:nvSpPr>
+        <p:spPr>
+          <a:xfrm>
+            <a:off x="7726679" y="5696712"/>
+            <a:ext cx="3931920" cy="237744"/>
+          </a:xfrm>
+          <a:prstGeom prst="rect">
+            <a:avLst/>
+          </a:prstGeom>
+          <a:noFill/>
+        </p:spPr>
+        <p:txBody>
+          <a:bodyPr wrap="square" lIns="0" tIns="0" rIns="0" bIns="0" anchor="t">
+            <a:spAutoFit/>
+          </a:bodyPr>
+          <a:lstStyle/>
+          <a:p>
+            <a:pPr algn="l"/>
+            <a:r>
+              <a:rPr sz="1000" b="0">
+                <a:solidFill>
+                  <a:srgbClr val="64748B"/>
+                </a:solidFill>
+                <a:latin typeface="Calibri"/>
+              </a:rPr>
+              <a:t>FAST 67 %, LANE 15 %, SLOWER 8 %</a:t>
+            </a:r>
+          </a:p>
+        </p:txBody>
+      </p:sp>
+      <p:sp>
+        <p:nvSpPr>
+          <p:cNvPr id="25" name="TextBox 24"/>
+          <p:cNvSpPr txBox="1"/>
+          <p:nvPr/>
+        </p:nvSpPr>
+        <p:spPr>
+          <a:xfrm>
+            <a:off x="7726679" y="5934456"/>
+            <a:ext cx="3931920" cy="237744"/>
+          </a:xfrm>
+          <a:prstGeom prst="rect">
+            <a:avLst/>
+          </a:prstGeom>
+          <a:noFill/>
+        </p:spPr>
+        <p:txBody>
+          <a:bodyPr wrap="square" lIns="0" tIns="0" rIns="0" bIns="0" anchor="t">
+            <a:spAutoFit/>
+          </a:bodyPr>
+          <a:lstStyle/>
+          <a:p>
+            <a:pPr algn="l"/>
+            <a:r>
+              <a:rPr sz="1000" b="0">
+                <a:solidFill>
+                  <a:srgbClr val="0F294B"/>
+                </a:solidFill>
+                <a:latin typeface="Calibri"/>
+              </a:rPr>
+              <a:t>uses lane changes — still crashes</a:t>
+            </a:r>
+          </a:p>
+        </p:txBody>
+      </p:sp>
+      <p:sp>
+        <p:nvSpPr>
+          <p:cNvPr id="26" name="Rounded Rectangle 25"/>
+          <p:cNvSpPr/>
+          <p:nvPr/>
+        </p:nvSpPr>
+        <p:spPr>
+          <a:xfrm>
+            <a:off x="457200" y="4069080"/>
+            <a:ext cx="6858000" cy="2240280"/>
+          </a:xfrm>
+          <a:prstGeom prst="roundRect">
+            <a:avLst/>
+          </a:prstGeom>
+          <a:solidFill>
+            <a:srgbClr val="F59E0B"/>
+          </a:solidFill>
+          <a:ln>
+            <a:noFill/>
+          </a:ln>
+          <a:effectLst/>
+        </p:spPr>
+        <p:style>
+          <a:lnRef idx="1">
+            <a:schemeClr val="accent1"/>
+          </a:lnRef>
+          <a:fillRef idx="3">
+            <a:schemeClr val="accent1"/>
+          </a:fillRef>
+          <a:effectRef idx="2">
+            <a:schemeClr val="accent1"/>
+          </a:effectRef>
+          <a:fontRef idx="minor">
+            <a:schemeClr val="lt1"/>
+          </a:fontRef>
+        </p:style>
+        <p:txBody>
+          <a:bodyPr rtlCol="0" anchor="ctr"/>
+          <a:lstStyle/>
+          <a:p>
+            <a:pPr algn="ctr"/>
+            <a:endParaRPr/>
+          </a:p>
+        </p:txBody>
+      </p:sp>
+      <p:sp>
+        <p:nvSpPr>
+          <p:cNvPr id="27" name="TextBox 26"/>
+          <p:cNvSpPr txBox="1"/>
+          <p:nvPr/>
+        </p:nvSpPr>
+        <p:spPr>
+          <a:xfrm>
+            <a:off x="685800" y="4206240"/>
+            <a:ext cx="6400800" cy="365760"/>
+          </a:xfrm>
+          <a:prstGeom prst="rect">
+            <a:avLst/>
+          </a:prstGeom>
+          <a:noFill/>
+        </p:spPr>
+        <p:txBody>
+          <a:bodyPr wrap="square" lIns="0" tIns="0" rIns="0" bIns="0" anchor="t">
+            <a:spAutoFit/>
+          </a:bodyPr>
+          <a:lstStyle/>
+          <a:p>
+            <a:pPr algn="l"/>
+            <a:r>
+              <a:rPr sz="1300" b="1">
+                <a:solidFill>
+                  <a:srgbClr val="0F294B"/>
+                </a:solidFill>
+                <a:latin typeface="Calibri"/>
+              </a:rPr>
+              <a:t>What the demo reveals</a:t>
+            </a:r>
+          </a:p>
+        </p:txBody>
+      </p:sp>
+      <p:sp>
+        <p:nvSpPr>
+          <p:cNvPr id="28" name="TextBox 27"/>
+          <p:cNvSpPr txBox="1"/>
+          <p:nvPr/>
+        </p:nvSpPr>
+        <p:spPr>
+          <a:xfrm>
+            <a:off x="685800" y="4572000"/>
+            <a:ext cx="6400800" cy="274320"/>
+          </a:xfrm>
+          <a:prstGeom prst="rect">
+            <a:avLst/>
+          </a:prstGeom>
+          <a:noFill/>
+        </p:spPr>
+        <p:txBody>
+          <a:bodyPr wrap="square" lIns="0" tIns="0" rIns="0" bIns="0" anchor="t">
+            <a:spAutoFit/>
+          </a:bodyPr>
+          <a:lstStyle/>
+          <a:p>
+            <a:pPr algn="l"/>
+            <a:r>
+              <a:rPr sz="1100" b="0">
+                <a:solidFill>
+                  <a:srgbClr val="0F294B"/>
+                </a:solidFill>
+                <a:latin typeface="Calibri"/>
+              </a:rPr>
+              <a:t>Linear-flow tasks (merge, highway):  policy collapses to ~100 % SLOWER.</a:t>
+            </a:r>
+          </a:p>
+        </p:txBody>
+      </p:sp>
+      <p:sp>
+        <p:nvSpPr>
+          <p:cNvPr id="29" name="TextBox 28"/>
+          <p:cNvSpPr txBox="1"/>
+          <p:nvPr/>
+        </p:nvSpPr>
+        <p:spPr>
+          <a:xfrm>
+            <a:off x="685800" y="4846320"/>
+            <a:ext cx="6400800" cy="274320"/>
+          </a:xfrm>
+          <a:prstGeom prst="rect">
+            <a:avLst/>
+          </a:prstGeom>
+          <a:noFill/>
+        </p:spPr>
+        <p:txBody>
+          <a:bodyPr wrap="square" lIns="0" tIns="0" rIns="0" bIns="0" anchor="t">
+            <a:spAutoFit/>
+          </a:bodyPr>
+          <a:lstStyle/>
+          <a:p>
+            <a:pPr algn="l"/>
+            <a:r>
+              <a:rPr sz="1100" b="0">
+                <a:solidFill>
+                  <a:srgbClr val="0F294B"/>
+                </a:solidFill>
+                <a:latin typeface="Calibri"/>
+              </a:rPr>
+              <a:t>Geometry-complex tasks (roundabout, intersection):  policy DOES use</a:t>
+            </a:r>
+          </a:p>
+        </p:txBody>
+      </p:sp>
+      <p:sp>
+        <p:nvSpPr>
+          <p:cNvPr id="30" name="TextBox 29"/>
+          <p:cNvSpPr txBox="1"/>
+          <p:nvPr/>
+        </p:nvSpPr>
+        <p:spPr>
+          <a:xfrm>
+            <a:off x="685800" y="5120640"/>
+            <a:ext cx="6400800" cy="274320"/>
+          </a:xfrm>
+          <a:prstGeom prst="rect">
+            <a:avLst/>
+          </a:prstGeom>
+          <a:noFill/>
+        </p:spPr>
+        <p:txBody>
+          <a:bodyPr wrap="square" lIns="0" tIns="0" rIns="0" bIns="0" anchor="t">
+            <a:spAutoFit/>
+          </a:bodyPr>
+          <a:lstStyle/>
+          <a:p>
+            <a:pPr algn="l"/>
+            <a:r>
+              <a:rPr sz="1100" b="0">
+                <a:solidFill>
+                  <a:srgbClr val="0F294B"/>
+                </a:solidFill>
+                <a:latin typeface="Calibri"/>
+              </a:rPr>
+              <a:t>12-15 % lane-change actions — but 3 k-step training is too short to</a:t>
+            </a:r>
+          </a:p>
+        </p:txBody>
+      </p:sp>
+      <p:sp>
+        <p:nvSpPr>
+          <p:cNvPr id="31" name="TextBox 30"/>
+          <p:cNvSpPr txBox="1"/>
+          <p:nvPr/>
+        </p:nvSpPr>
+        <p:spPr>
+          <a:xfrm>
+            <a:off x="685800" y="5394960"/>
+            <a:ext cx="6400800" cy="274320"/>
+          </a:xfrm>
+          <a:prstGeom prst="rect">
+            <a:avLst/>
+          </a:prstGeom>
+          <a:noFill/>
+        </p:spPr>
+        <p:txBody>
+          <a:bodyPr wrap="square" lIns="0" tIns="0" rIns="0" bIns="0" anchor="t">
+            <a:spAutoFit/>
+          </a:bodyPr>
+          <a:lstStyle/>
+          <a:p>
+            <a:pPr algn="l"/>
+            <a:r>
+              <a:rPr sz="1100" b="0">
+                <a:solidFill>
+                  <a:srgbClr val="0F294B"/>
+                </a:solidFill>
+                <a:latin typeface="Calibri"/>
+              </a:rPr>
+              <a:t>drive them well, so crash rate stays at 33-50 %.</a:t>
+            </a:r>
+          </a:p>
+        </p:txBody>
+      </p:sp>
+      <p:sp>
+        <p:nvSpPr>
+          <p:cNvPr id="32" name="TextBox 31"/>
+          <p:cNvSpPr txBox="1"/>
+          <p:nvPr/>
+        </p:nvSpPr>
+        <p:spPr>
+          <a:xfrm>
+            <a:off x="685800" y="5669280"/>
+            <a:ext cx="6400800" cy="274320"/>
+          </a:xfrm>
+          <a:prstGeom prst="rect">
+            <a:avLst/>
+          </a:prstGeom>
+          <a:noFill/>
+        </p:spPr>
+        <p:txBody>
+          <a:bodyPr wrap="square" lIns="0" tIns="0" rIns="0" bIns="0" anchor="t">
+            <a:spAutoFit/>
+          </a:bodyPr>
+          <a:lstStyle/>
+          <a:p>
+            <a:pPr algn="l"/>
+            <a:endParaRPr/>
+          </a:p>
+        </p:txBody>
+      </p:sp>
+      <p:sp>
+        <p:nvSpPr>
+          <p:cNvPr id="33" name="TextBox 32"/>
+          <p:cNvSpPr txBox="1"/>
+          <p:nvPr/>
+        </p:nvSpPr>
+        <p:spPr>
+          <a:xfrm>
+            <a:off x="685800" y="5943600"/>
+            <a:ext cx="6400800" cy="274320"/>
+          </a:xfrm>
+          <a:prstGeom prst="rect">
+            <a:avLst/>
+          </a:prstGeom>
+          <a:noFill/>
+        </p:spPr>
+        <p:txBody>
+          <a:bodyPr wrap="square" lIns="0" tIns="0" rIns="0" bIns="0" anchor="t">
+            <a:spAutoFit/>
+          </a:bodyPr>
+          <a:lstStyle/>
+          <a:p>
+            <a:pPr algn="l"/>
+            <a:r>
+              <a:rPr sz="1100" b="1">
+                <a:solidFill>
+                  <a:srgbClr val="0F294B"/>
+                </a:solidFill>
+                <a:latin typeface="Calibri"/>
+              </a:rPr>
+              <a:t>Confirms paper's claim is robust on linear merges; open on intersections.</a:t>
+            </a:r>
+          </a:p>
+        </p:txBody>
+      </p:sp>
+      <p:sp>
+        <p:nvSpPr>
+          <p:cNvPr id="34" name="TextBox 33"/>
           <p:cNvSpPr txBox="1"/>
           <p:nvPr/>
         </p:nvSpPr>
@@ -6488,1216 +7735,6 @@
                 </a:solidFill>
                 <a:latin typeface="Calibri"/>
               </a:rPr>
-              <a:t>All four scenarios — what each policy learns</a:t>
-            </a:r>
-          </a:p>
-        </p:txBody>
-      </p:sp>
-      <p:sp>
-        <p:nvSpPr>
-          <p:cNvPr id="4" name="TextBox 3"/>
-          <p:cNvSpPr txBox="1"/>
-          <p:nvPr/>
-        </p:nvSpPr>
-        <p:spPr>
-          <a:xfrm>
-            <a:off x="10607040" y="164592"/>
-            <a:ext cx="1554480" cy="365760"/>
-          </a:xfrm>
-          <a:prstGeom prst="rect">
-            <a:avLst/>
-          </a:prstGeom>
-          <a:noFill/>
-        </p:spPr>
-        <p:txBody>
-          <a:bodyPr wrap="square" lIns="0" tIns="0" rIns="0" bIns="0" anchor="t">
-            <a:spAutoFit/>
-          </a:bodyPr>
-          <a:lstStyle/>
-          <a:p>
-            <a:pPr algn="r"/>
-            <a:r>
-              <a:rPr sz="1200" b="0">
-                <a:solidFill>
-                  <a:srgbClr val="CBD5E1"/>
-                </a:solidFill>
-                <a:latin typeface="Calibri"/>
-              </a:rPr>
-              <a:t>14 / 16</a:t>
-            </a:r>
-          </a:p>
-        </p:txBody>
-      </p:sp>
-      <p:sp>
-        <p:nvSpPr>
-          <p:cNvPr id="5" name="TextBox 4"/>
-          <p:cNvSpPr txBox="1"/>
-          <p:nvPr/>
-        </p:nvSpPr>
-        <p:spPr>
-          <a:xfrm>
-            <a:off x="457200" y="868680"/>
-            <a:ext cx="10972800" cy="411480"/>
-          </a:xfrm>
-          <a:prstGeom prst="rect">
-            <a:avLst/>
-          </a:prstGeom>
-          <a:noFill/>
-        </p:spPr>
-        <p:txBody>
-          <a:bodyPr wrap="square" lIns="0" tIns="0" rIns="0" bIns="0" anchor="t">
-            <a:spAutoFit/>
-          </a:bodyPr>
-          <a:lstStyle/>
-          <a:p>
-            <a:pPr algn="l"/>
-            <a:r>
-              <a:rPr sz="1400" b="0">
-                <a:solidFill>
-                  <a:srgbClr val="64748B"/>
-                </a:solidFill>
-                <a:latin typeface="Calibri"/>
-              </a:rPr>
-              <a:t>20-second tour: each env plays for ~5 s with its own trained policy.  File:  all_envs_demo.mp4</a:t>
-            </a:r>
-          </a:p>
-        </p:txBody>
-      </p:sp>
-      <p:pic>
-        <p:nvPicPr>
-          <p:cNvPr id="6" name="Picture 5" descr="all_envs_poster.png"/>
-          <p:cNvPicPr>
-            <a:picLocks noChangeAspect="1"/>
-          </p:cNvPicPr>
-          <p:nvPr/>
-        </p:nvPicPr>
-        <p:blipFill>
-          <a:blip r:embed="rId5"/>
-          <a:stretch>
-            <a:fillRect/>
-          </a:stretch>
-        </p:blipFill>
-        <p:spPr>
-          <a:xfrm>
-            <a:off x="457200" y="1417320"/>
-            <a:ext cx="6858000" cy="2971800"/>
-          </a:xfrm>
-          <a:prstGeom prst="rect">
-            <a:avLst/>
-          </a:prstGeom>
-        </p:spPr>
-      </p:pic>
-      <p:pic>
-        <p:nvPicPr>
-          <p:cNvPr id="7" name="all_envs_demo.mp4">
-            <a:hlinkClick r:id="" action="ppaction://media"/>
-          </p:cNvPr>
-          <p:cNvPicPr>
-            <a:picLocks noChangeAspect="1"/>
-          </p:cNvPicPr>
-          <p:nvPr>
-            <a:videoFile r:link="rId2"/>
-            <p:extLst>
-              <p:ext uri="{DAA4B4D4-6D71-4841-9C94-3DE7FCFB9230}">
-                <p14:media xmlns:p14="http://schemas.microsoft.com/office/powerpoint/2010/main" r:embed="rId1"/>
-              </p:ext>
-            </p:extLst>
-          </p:nvPr>
-        </p:nvPicPr>
-        <p:blipFill>
-          <a:blip r:embed="rId5"/>
-          <a:stretch>
-            <a:fillRect/>
-          </a:stretch>
-        </p:blipFill>
-        <p:spPr>
-          <a:xfrm>
-            <a:off x="457200" y="1417320"/>
-            <a:ext cx="6858000" cy="2468880"/>
-          </a:xfrm>
-          <a:prstGeom prst="rect">
-            <a:avLst/>
-          </a:prstGeom>
-        </p:spPr>
-      </p:pic>
-      <p:sp>
-        <p:nvSpPr>
-          <p:cNvPr id="8" name="Rounded Rectangle 7"/>
-          <p:cNvSpPr/>
-          <p:nvPr/>
-        </p:nvSpPr>
-        <p:spPr>
-          <a:xfrm>
-            <a:off x="7543800" y="1417320"/>
-            <a:ext cx="4206240" cy="4892040"/>
-          </a:xfrm>
-          <a:prstGeom prst="roundRect">
-            <a:avLst/>
-          </a:prstGeom>
-          <a:solidFill>
-            <a:srgbClr val="F8FAFC"/>
-          </a:solidFill>
-          <a:ln>
-            <a:noFill/>
-          </a:ln>
-          <a:effectLst/>
-        </p:spPr>
-        <p:style>
-          <a:lnRef idx="1">
-            <a:schemeClr val="accent1"/>
-          </a:lnRef>
-          <a:fillRef idx="3">
-            <a:schemeClr val="accent1"/>
-          </a:fillRef>
-          <a:effectRef idx="2">
-            <a:schemeClr val="accent1"/>
-          </a:effectRef>
-          <a:fontRef idx="minor">
-            <a:schemeClr val="lt1"/>
-          </a:fontRef>
-        </p:style>
-        <p:txBody>
-          <a:bodyPr rtlCol="0" anchor="ctr"/>
-          <a:lstStyle/>
-          <a:p>
-            <a:pPr algn="ctr"/>
-            <a:endParaRPr/>
-          </a:p>
-        </p:txBody>
-      </p:sp>
-      <p:sp>
-        <p:nvSpPr>
-          <p:cNvPr id="9" name="TextBox 8"/>
-          <p:cNvSpPr txBox="1"/>
-          <p:nvPr/>
-        </p:nvSpPr>
-        <p:spPr>
-          <a:xfrm>
-            <a:off x="7726679" y="1554480"/>
-            <a:ext cx="3931920" cy="365760"/>
-          </a:xfrm>
-          <a:prstGeom prst="rect">
-            <a:avLst/>
-          </a:prstGeom>
-          <a:noFill/>
-        </p:spPr>
-        <p:txBody>
-          <a:bodyPr wrap="square" lIns="0" tIns="0" rIns="0" bIns="0" anchor="t">
-            <a:spAutoFit/>
-          </a:bodyPr>
-          <a:lstStyle/>
-          <a:p>
-            <a:pPr algn="l"/>
-            <a:r>
-              <a:rPr sz="1300" b="1">
-                <a:solidFill>
-                  <a:srgbClr val="2563EB"/>
-                </a:solidFill>
-                <a:latin typeface="Calibri"/>
-              </a:rPr>
-              <a:t>Per-scenario behaviour</a:t>
-            </a:r>
-          </a:p>
-        </p:txBody>
-      </p:sp>
-      <p:sp>
-        <p:nvSpPr>
-          <p:cNvPr id="10" name="TextBox 9"/>
-          <p:cNvSpPr txBox="1"/>
-          <p:nvPr/>
-        </p:nvSpPr>
-        <p:spPr>
-          <a:xfrm>
-            <a:off x="7726679" y="1965960"/>
-            <a:ext cx="3931920" cy="256032"/>
-          </a:xfrm>
-          <a:prstGeom prst="rect">
-            <a:avLst/>
-          </a:prstGeom>
-          <a:noFill/>
-        </p:spPr>
-        <p:txBody>
-          <a:bodyPr wrap="square" lIns="0" tIns="0" rIns="0" bIns="0" anchor="t">
-            <a:spAutoFit/>
-          </a:bodyPr>
-          <a:lstStyle/>
-          <a:p>
-            <a:pPr algn="l"/>
-            <a:r>
-              <a:rPr sz="1200" b="1">
-                <a:solidFill>
-                  <a:srgbClr val="16A34A"/>
-                </a:solidFill>
-                <a:latin typeface="Calibri"/>
-              </a:rPr>
-              <a:t>Merge</a:t>
-            </a:r>
-          </a:p>
-        </p:txBody>
-      </p:sp>
-      <p:sp>
-        <p:nvSpPr>
-          <p:cNvPr id="11" name="TextBox 10"/>
-          <p:cNvSpPr txBox="1"/>
-          <p:nvPr/>
-        </p:nvSpPr>
-        <p:spPr>
-          <a:xfrm>
-            <a:off x="7726679" y="2221992"/>
-            <a:ext cx="3931920" cy="237744"/>
-          </a:xfrm>
-          <a:prstGeom prst="rect">
-            <a:avLst/>
-          </a:prstGeom>
-          <a:noFill/>
-        </p:spPr>
-        <p:txBody>
-          <a:bodyPr wrap="square" lIns="0" tIns="0" rIns="0" bIns="0" anchor="t">
-            <a:spAutoFit/>
-          </a:bodyPr>
-          <a:lstStyle/>
-          <a:p>
-            <a:pPr algn="l"/>
-            <a:r>
-              <a:rPr sz="1000" b="1">
-                <a:solidFill>
-                  <a:srgbClr val="0F294B"/>
-                </a:solidFill>
-                <a:latin typeface="Calibri"/>
-              </a:rPr>
-              <a:t>0/3 crashes  (0 %)</a:t>
-            </a:r>
-          </a:p>
-        </p:txBody>
-      </p:sp>
-      <p:sp>
-        <p:nvSpPr>
-          <p:cNvPr id="12" name="TextBox 11"/>
-          <p:cNvSpPr txBox="1"/>
-          <p:nvPr/>
-        </p:nvSpPr>
-        <p:spPr>
-          <a:xfrm>
-            <a:off x="7726679" y="2459736"/>
-            <a:ext cx="3931920" cy="237744"/>
-          </a:xfrm>
-          <a:prstGeom prst="rect">
-            <a:avLst/>
-          </a:prstGeom>
-          <a:noFill/>
-        </p:spPr>
-        <p:txBody>
-          <a:bodyPr wrap="square" lIns="0" tIns="0" rIns="0" bIns="0" anchor="t">
-            <a:spAutoFit/>
-          </a:bodyPr>
-          <a:lstStyle/>
-          <a:p>
-            <a:pPr algn="l"/>
-            <a:r>
-              <a:rPr sz="1000" b="0">
-                <a:solidFill>
-                  <a:srgbClr val="64748B"/>
-                </a:solidFill>
-                <a:latin typeface="Calibri"/>
-              </a:rPr>
-              <a:t>SLOWER 97 %, IDLE 3 %</a:t>
-            </a:r>
-          </a:p>
-        </p:txBody>
-      </p:sp>
-      <p:sp>
-        <p:nvSpPr>
-          <p:cNvPr id="13" name="TextBox 12"/>
-          <p:cNvSpPr txBox="1"/>
-          <p:nvPr/>
-        </p:nvSpPr>
-        <p:spPr>
-          <a:xfrm>
-            <a:off x="7726679" y="2697480"/>
-            <a:ext cx="3931920" cy="237744"/>
-          </a:xfrm>
-          <a:prstGeom prst="rect">
-            <a:avLst/>
-          </a:prstGeom>
-          <a:noFill/>
-        </p:spPr>
-        <p:txBody>
-          <a:bodyPr wrap="square" lIns="0" tIns="0" rIns="0" bIns="0" anchor="t">
-            <a:spAutoFit/>
-          </a:bodyPr>
-          <a:lstStyle/>
-          <a:p>
-            <a:pPr algn="l"/>
-            <a:r>
-              <a:rPr sz="1000" b="0">
-                <a:solidFill>
-                  <a:srgbClr val="0F294B"/>
-                </a:solidFill>
-                <a:latin typeface="Calibri"/>
-              </a:rPr>
-              <a:t>brake-only — geometry forces merge</a:t>
-            </a:r>
-          </a:p>
-        </p:txBody>
-      </p:sp>
-      <p:sp>
-        <p:nvSpPr>
-          <p:cNvPr id="14" name="TextBox 13"/>
-          <p:cNvSpPr txBox="1"/>
-          <p:nvPr/>
-        </p:nvSpPr>
-        <p:spPr>
-          <a:xfrm>
-            <a:off x="7726679" y="3044952"/>
-            <a:ext cx="3931920" cy="256032"/>
-          </a:xfrm>
-          <a:prstGeom prst="rect">
-            <a:avLst/>
-          </a:prstGeom>
-          <a:noFill/>
-        </p:spPr>
-        <p:txBody>
-          <a:bodyPr wrap="square" lIns="0" tIns="0" rIns="0" bIns="0" anchor="t">
-            <a:spAutoFit/>
-          </a:bodyPr>
-          <a:lstStyle/>
-          <a:p>
-            <a:pPr algn="l"/>
-            <a:r>
-              <a:rPr sz="1200" b="1">
-                <a:solidFill>
-                  <a:srgbClr val="2563EB"/>
-                </a:solidFill>
-                <a:latin typeface="Calibri"/>
-              </a:rPr>
-              <a:t>Highway</a:t>
-            </a:r>
-          </a:p>
-        </p:txBody>
-      </p:sp>
-      <p:sp>
-        <p:nvSpPr>
-          <p:cNvPr id="15" name="TextBox 14"/>
-          <p:cNvSpPr txBox="1"/>
-          <p:nvPr/>
-        </p:nvSpPr>
-        <p:spPr>
-          <a:xfrm>
-            <a:off x="7726679" y="3300984"/>
-            <a:ext cx="3931920" cy="237744"/>
-          </a:xfrm>
-          <a:prstGeom prst="rect">
-            <a:avLst/>
-          </a:prstGeom>
-          <a:noFill/>
-        </p:spPr>
-        <p:txBody>
-          <a:bodyPr wrap="square" lIns="0" tIns="0" rIns="0" bIns="0" anchor="t">
-            <a:spAutoFit/>
-          </a:bodyPr>
-          <a:lstStyle/>
-          <a:p>
-            <a:pPr algn="l"/>
-            <a:r>
-              <a:rPr sz="1000" b="1">
-                <a:solidFill>
-                  <a:srgbClr val="0F294B"/>
-                </a:solidFill>
-                <a:latin typeface="Calibri"/>
-              </a:rPr>
-              <a:t>0/1 crashes  (0 %)</a:t>
-            </a:r>
-          </a:p>
-        </p:txBody>
-      </p:sp>
-      <p:sp>
-        <p:nvSpPr>
-          <p:cNvPr id="16" name="TextBox 15"/>
-          <p:cNvSpPr txBox="1"/>
-          <p:nvPr/>
-        </p:nvSpPr>
-        <p:spPr>
-          <a:xfrm>
-            <a:off x="7726679" y="3538728"/>
-            <a:ext cx="3931920" cy="237744"/>
-          </a:xfrm>
-          <a:prstGeom prst="rect">
-            <a:avLst/>
-          </a:prstGeom>
-          <a:noFill/>
-        </p:spPr>
-        <p:txBody>
-          <a:bodyPr wrap="square" lIns="0" tIns="0" rIns="0" bIns="0" anchor="t">
-            <a:spAutoFit/>
-          </a:bodyPr>
-          <a:lstStyle/>
-          <a:p>
-            <a:pPr algn="l"/>
-            <a:r>
-              <a:rPr sz="1000" b="0">
-                <a:solidFill>
-                  <a:srgbClr val="64748B"/>
-                </a:solidFill>
-                <a:latin typeface="Calibri"/>
-              </a:rPr>
-              <a:t>SLOWER 100 %</a:t>
-            </a:r>
-          </a:p>
-        </p:txBody>
-      </p:sp>
-      <p:sp>
-        <p:nvSpPr>
-          <p:cNvPr id="17" name="TextBox 16"/>
-          <p:cNvSpPr txBox="1"/>
-          <p:nvPr/>
-        </p:nvSpPr>
-        <p:spPr>
-          <a:xfrm>
-            <a:off x="7726679" y="3776472"/>
-            <a:ext cx="3931920" cy="237744"/>
-          </a:xfrm>
-          <a:prstGeom prst="rect">
-            <a:avLst/>
-          </a:prstGeom>
-          <a:noFill/>
-        </p:spPr>
-        <p:txBody>
-          <a:bodyPr wrap="square" lIns="0" tIns="0" rIns="0" bIns="0" anchor="t">
-            <a:spAutoFit/>
-          </a:bodyPr>
-          <a:lstStyle/>
-          <a:p>
-            <a:pPr algn="l"/>
-            <a:r>
-              <a:rPr sz="1000" b="0">
-                <a:solidFill>
-                  <a:srgbClr val="0F294B"/>
-                </a:solidFill>
-                <a:latin typeface="Calibri"/>
-              </a:rPr>
-              <a:t>brake-only — lazy optimum</a:t>
-            </a:r>
-          </a:p>
-        </p:txBody>
-      </p:sp>
-      <p:sp>
-        <p:nvSpPr>
-          <p:cNvPr id="18" name="TextBox 17"/>
-          <p:cNvSpPr txBox="1"/>
-          <p:nvPr/>
-        </p:nvSpPr>
-        <p:spPr>
-          <a:xfrm>
-            <a:off x="7726679" y="4123944"/>
-            <a:ext cx="3931920" cy="256032"/>
-          </a:xfrm>
-          <a:prstGeom prst="rect">
-            <a:avLst/>
-          </a:prstGeom>
-          <a:noFill/>
-        </p:spPr>
-        <p:txBody>
-          <a:bodyPr wrap="square" lIns="0" tIns="0" rIns="0" bIns="0" anchor="t">
-            <a:spAutoFit/>
-          </a:bodyPr>
-          <a:lstStyle/>
-          <a:p>
-            <a:pPr algn="l"/>
-            <a:r>
-              <a:rPr sz="1200" b="1">
-                <a:solidFill>
-                  <a:srgbClr val="DC2626"/>
-                </a:solidFill>
-                <a:latin typeface="Calibri"/>
-              </a:rPr>
-              <a:t>Roundabout</a:t>
-            </a:r>
-          </a:p>
-        </p:txBody>
-      </p:sp>
-      <p:sp>
-        <p:nvSpPr>
-          <p:cNvPr id="19" name="TextBox 18"/>
-          <p:cNvSpPr txBox="1"/>
-          <p:nvPr/>
-        </p:nvSpPr>
-        <p:spPr>
-          <a:xfrm>
-            <a:off x="7726679" y="4379976"/>
-            <a:ext cx="3931920" cy="237744"/>
-          </a:xfrm>
-          <a:prstGeom prst="rect">
-            <a:avLst/>
-          </a:prstGeom>
-          <a:noFill/>
-        </p:spPr>
-        <p:txBody>
-          <a:bodyPr wrap="square" lIns="0" tIns="0" rIns="0" bIns="0" anchor="t">
-            <a:spAutoFit/>
-          </a:bodyPr>
-          <a:lstStyle/>
-          <a:p>
-            <a:pPr algn="l"/>
-            <a:r>
-              <a:rPr sz="1000" b="1">
-                <a:solidFill>
-                  <a:srgbClr val="0F294B"/>
-                </a:solidFill>
-                <a:latin typeface="Calibri"/>
-              </a:rPr>
-              <a:t>2/6 crashes  (33 %)</a:t>
-            </a:r>
-          </a:p>
-        </p:txBody>
-      </p:sp>
-      <p:sp>
-        <p:nvSpPr>
-          <p:cNvPr id="20" name="TextBox 19"/>
-          <p:cNvSpPr txBox="1"/>
-          <p:nvPr/>
-        </p:nvSpPr>
-        <p:spPr>
-          <a:xfrm>
-            <a:off x="7726679" y="4617720"/>
-            <a:ext cx="3931920" cy="237744"/>
-          </a:xfrm>
-          <a:prstGeom prst="rect">
-            <a:avLst/>
-          </a:prstGeom>
-          <a:noFill/>
-        </p:spPr>
-        <p:txBody>
-          <a:bodyPr wrap="square" lIns="0" tIns="0" rIns="0" bIns="0" anchor="t">
-            <a:spAutoFit/>
-          </a:bodyPr>
-          <a:lstStyle/>
-          <a:p>
-            <a:pPr algn="l"/>
-            <a:r>
-              <a:rPr sz="1000" b="0">
-                <a:solidFill>
-                  <a:srgbClr val="64748B"/>
-                </a:solidFill>
-                <a:latin typeface="Calibri"/>
-              </a:rPr>
-              <a:t>FAST 53 %, IDLE 22 %, LANE 13 %</a:t>
-            </a:r>
-          </a:p>
-        </p:txBody>
-      </p:sp>
-      <p:sp>
-        <p:nvSpPr>
-          <p:cNvPr id="21" name="TextBox 20"/>
-          <p:cNvSpPr txBox="1"/>
-          <p:nvPr/>
-        </p:nvSpPr>
-        <p:spPr>
-          <a:xfrm>
-            <a:off x="7726679" y="4855464"/>
-            <a:ext cx="3931920" cy="237744"/>
-          </a:xfrm>
-          <a:prstGeom prst="rect">
-            <a:avLst/>
-          </a:prstGeom>
-          <a:noFill/>
-        </p:spPr>
-        <p:txBody>
-          <a:bodyPr wrap="square" lIns="0" tIns="0" rIns="0" bIns="0" anchor="t">
-            <a:spAutoFit/>
-          </a:bodyPr>
-          <a:lstStyle/>
-          <a:p>
-            <a:pPr algn="l"/>
-            <a:r>
-              <a:rPr sz="1000" b="0">
-                <a:solidFill>
-                  <a:srgbClr val="0F294B"/>
-                </a:solidFill>
-                <a:latin typeface="Calibri"/>
-              </a:rPr>
-              <a:t>uses lane changes — still crashes</a:t>
-            </a:r>
-          </a:p>
-        </p:txBody>
-      </p:sp>
-      <p:sp>
-        <p:nvSpPr>
-          <p:cNvPr id="22" name="TextBox 21"/>
-          <p:cNvSpPr txBox="1"/>
-          <p:nvPr/>
-        </p:nvSpPr>
-        <p:spPr>
-          <a:xfrm>
-            <a:off x="7726679" y="5202936"/>
-            <a:ext cx="3931920" cy="256032"/>
-          </a:xfrm>
-          <a:prstGeom prst="rect">
-            <a:avLst/>
-          </a:prstGeom>
-          <a:noFill/>
-        </p:spPr>
-        <p:txBody>
-          <a:bodyPr wrap="square" lIns="0" tIns="0" rIns="0" bIns="0" anchor="t">
-            <a:spAutoFit/>
-          </a:bodyPr>
-          <a:lstStyle/>
-          <a:p>
-            <a:pPr algn="l"/>
-            <a:r>
-              <a:rPr sz="1200" b="1">
-                <a:solidFill>
-                  <a:srgbClr val="DC2626"/>
-                </a:solidFill>
-                <a:latin typeface="Calibri"/>
-              </a:rPr>
-              <a:t>Intersection</a:t>
-            </a:r>
-          </a:p>
-        </p:txBody>
-      </p:sp>
-      <p:sp>
-        <p:nvSpPr>
-          <p:cNvPr id="23" name="TextBox 22"/>
-          <p:cNvSpPr txBox="1"/>
-          <p:nvPr/>
-        </p:nvSpPr>
-        <p:spPr>
-          <a:xfrm>
-            <a:off x="7726679" y="5458968"/>
-            <a:ext cx="3931920" cy="237744"/>
-          </a:xfrm>
-          <a:prstGeom prst="rect">
-            <a:avLst/>
-          </a:prstGeom>
-          <a:noFill/>
-        </p:spPr>
-        <p:txBody>
-          <a:bodyPr wrap="square" lIns="0" tIns="0" rIns="0" bIns="0" anchor="t">
-            <a:spAutoFit/>
-          </a:bodyPr>
-          <a:lstStyle/>
-          <a:p>
-            <a:pPr algn="l"/>
-            <a:r>
-              <a:rPr sz="1000" b="1">
-                <a:solidFill>
-                  <a:srgbClr val="0F294B"/>
-                </a:solidFill>
-                <a:latin typeface="Calibri"/>
-              </a:rPr>
-              <a:t>9/18 crashes  (50 %)</a:t>
-            </a:r>
-          </a:p>
-        </p:txBody>
-      </p:sp>
-      <p:sp>
-        <p:nvSpPr>
-          <p:cNvPr id="24" name="TextBox 23"/>
-          <p:cNvSpPr txBox="1"/>
-          <p:nvPr/>
-        </p:nvSpPr>
-        <p:spPr>
-          <a:xfrm>
-            <a:off x="7726679" y="5696712"/>
-            <a:ext cx="3931920" cy="237744"/>
-          </a:xfrm>
-          <a:prstGeom prst="rect">
-            <a:avLst/>
-          </a:prstGeom>
-          <a:noFill/>
-        </p:spPr>
-        <p:txBody>
-          <a:bodyPr wrap="square" lIns="0" tIns="0" rIns="0" bIns="0" anchor="t">
-            <a:spAutoFit/>
-          </a:bodyPr>
-          <a:lstStyle/>
-          <a:p>
-            <a:pPr algn="l"/>
-            <a:r>
-              <a:rPr sz="1000" b="0">
-                <a:solidFill>
-                  <a:srgbClr val="64748B"/>
-                </a:solidFill>
-                <a:latin typeface="Calibri"/>
-              </a:rPr>
-              <a:t>FAST 67 %, LANE 15 %, SLOWER 8 %</a:t>
-            </a:r>
-          </a:p>
-        </p:txBody>
-      </p:sp>
-      <p:sp>
-        <p:nvSpPr>
-          <p:cNvPr id="25" name="TextBox 24"/>
-          <p:cNvSpPr txBox="1"/>
-          <p:nvPr/>
-        </p:nvSpPr>
-        <p:spPr>
-          <a:xfrm>
-            <a:off x="7726679" y="5934456"/>
-            <a:ext cx="3931920" cy="237744"/>
-          </a:xfrm>
-          <a:prstGeom prst="rect">
-            <a:avLst/>
-          </a:prstGeom>
-          <a:noFill/>
-        </p:spPr>
-        <p:txBody>
-          <a:bodyPr wrap="square" lIns="0" tIns="0" rIns="0" bIns="0" anchor="t">
-            <a:spAutoFit/>
-          </a:bodyPr>
-          <a:lstStyle/>
-          <a:p>
-            <a:pPr algn="l"/>
-            <a:r>
-              <a:rPr sz="1000" b="0">
-                <a:solidFill>
-                  <a:srgbClr val="0F294B"/>
-                </a:solidFill>
-                <a:latin typeface="Calibri"/>
-              </a:rPr>
-              <a:t>uses lane changes — still crashes</a:t>
-            </a:r>
-          </a:p>
-        </p:txBody>
-      </p:sp>
-      <p:sp>
-        <p:nvSpPr>
-          <p:cNvPr id="26" name="Rounded Rectangle 25"/>
-          <p:cNvSpPr/>
-          <p:nvPr/>
-        </p:nvSpPr>
-        <p:spPr>
-          <a:xfrm>
-            <a:off x="457200" y="4069080"/>
-            <a:ext cx="6858000" cy="2240280"/>
-          </a:xfrm>
-          <a:prstGeom prst="roundRect">
-            <a:avLst/>
-          </a:prstGeom>
-          <a:solidFill>
-            <a:srgbClr val="F59E0B"/>
-          </a:solidFill>
-          <a:ln>
-            <a:noFill/>
-          </a:ln>
-          <a:effectLst/>
-        </p:spPr>
-        <p:style>
-          <a:lnRef idx="1">
-            <a:schemeClr val="accent1"/>
-          </a:lnRef>
-          <a:fillRef idx="3">
-            <a:schemeClr val="accent1"/>
-          </a:fillRef>
-          <a:effectRef idx="2">
-            <a:schemeClr val="accent1"/>
-          </a:effectRef>
-          <a:fontRef idx="minor">
-            <a:schemeClr val="lt1"/>
-          </a:fontRef>
-        </p:style>
-        <p:txBody>
-          <a:bodyPr rtlCol="0" anchor="ctr"/>
-          <a:lstStyle/>
-          <a:p>
-            <a:pPr algn="ctr"/>
-            <a:endParaRPr/>
-          </a:p>
-        </p:txBody>
-      </p:sp>
-      <p:sp>
-        <p:nvSpPr>
-          <p:cNvPr id="27" name="TextBox 26"/>
-          <p:cNvSpPr txBox="1"/>
-          <p:nvPr/>
-        </p:nvSpPr>
-        <p:spPr>
-          <a:xfrm>
-            <a:off x="685800" y="4206240"/>
-            <a:ext cx="6400800" cy="365760"/>
-          </a:xfrm>
-          <a:prstGeom prst="rect">
-            <a:avLst/>
-          </a:prstGeom>
-          <a:noFill/>
-        </p:spPr>
-        <p:txBody>
-          <a:bodyPr wrap="square" lIns="0" tIns="0" rIns="0" bIns="0" anchor="t">
-            <a:spAutoFit/>
-          </a:bodyPr>
-          <a:lstStyle/>
-          <a:p>
-            <a:pPr algn="l"/>
-            <a:r>
-              <a:rPr sz="1300" b="1">
-                <a:solidFill>
-                  <a:srgbClr val="0F294B"/>
-                </a:solidFill>
-                <a:latin typeface="Calibri"/>
-              </a:rPr>
-              <a:t>What the demo reveals</a:t>
-            </a:r>
-          </a:p>
-        </p:txBody>
-      </p:sp>
-      <p:sp>
-        <p:nvSpPr>
-          <p:cNvPr id="28" name="TextBox 27"/>
-          <p:cNvSpPr txBox="1"/>
-          <p:nvPr/>
-        </p:nvSpPr>
-        <p:spPr>
-          <a:xfrm>
-            <a:off x="685800" y="4572000"/>
-            <a:ext cx="6400800" cy="274320"/>
-          </a:xfrm>
-          <a:prstGeom prst="rect">
-            <a:avLst/>
-          </a:prstGeom>
-          <a:noFill/>
-        </p:spPr>
-        <p:txBody>
-          <a:bodyPr wrap="square" lIns="0" tIns="0" rIns="0" bIns="0" anchor="t">
-            <a:spAutoFit/>
-          </a:bodyPr>
-          <a:lstStyle/>
-          <a:p>
-            <a:pPr algn="l"/>
-            <a:r>
-              <a:rPr sz="1100" b="0">
-                <a:solidFill>
-                  <a:srgbClr val="0F294B"/>
-                </a:solidFill>
-                <a:latin typeface="Calibri"/>
-              </a:rPr>
-              <a:t>Linear-flow tasks (merge, highway):  policy collapses to ~100 % SLOWER.</a:t>
-            </a:r>
-          </a:p>
-        </p:txBody>
-      </p:sp>
-      <p:sp>
-        <p:nvSpPr>
-          <p:cNvPr id="29" name="TextBox 28"/>
-          <p:cNvSpPr txBox="1"/>
-          <p:nvPr/>
-        </p:nvSpPr>
-        <p:spPr>
-          <a:xfrm>
-            <a:off x="685800" y="4846320"/>
-            <a:ext cx="6400800" cy="274320"/>
-          </a:xfrm>
-          <a:prstGeom prst="rect">
-            <a:avLst/>
-          </a:prstGeom>
-          <a:noFill/>
-        </p:spPr>
-        <p:txBody>
-          <a:bodyPr wrap="square" lIns="0" tIns="0" rIns="0" bIns="0" anchor="t">
-            <a:spAutoFit/>
-          </a:bodyPr>
-          <a:lstStyle/>
-          <a:p>
-            <a:pPr algn="l"/>
-            <a:r>
-              <a:rPr sz="1100" b="0">
-                <a:solidFill>
-                  <a:srgbClr val="0F294B"/>
-                </a:solidFill>
-                <a:latin typeface="Calibri"/>
-              </a:rPr>
-              <a:t>Geometry-complex tasks (roundabout, intersection):  policy DOES use</a:t>
-            </a:r>
-          </a:p>
-        </p:txBody>
-      </p:sp>
-      <p:sp>
-        <p:nvSpPr>
-          <p:cNvPr id="30" name="TextBox 29"/>
-          <p:cNvSpPr txBox="1"/>
-          <p:nvPr/>
-        </p:nvSpPr>
-        <p:spPr>
-          <a:xfrm>
-            <a:off x="685800" y="5120640"/>
-            <a:ext cx="6400800" cy="274320"/>
-          </a:xfrm>
-          <a:prstGeom prst="rect">
-            <a:avLst/>
-          </a:prstGeom>
-          <a:noFill/>
-        </p:spPr>
-        <p:txBody>
-          <a:bodyPr wrap="square" lIns="0" tIns="0" rIns="0" bIns="0" anchor="t">
-            <a:spAutoFit/>
-          </a:bodyPr>
-          <a:lstStyle/>
-          <a:p>
-            <a:pPr algn="l"/>
-            <a:r>
-              <a:rPr sz="1100" b="0">
-                <a:solidFill>
-                  <a:srgbClr val="0F294B"/>
-                </a:solidFill>
-                <a:latin typeface="Calibri"/>
-              </a:rPr>
-              <a:t>12-15 % lane-change actions — but 3 k-step training is too short to</a:t>
-            </a:r>
-          </a:p>
-        </p:txBody>
-      </p:sp>
-      <p:sp>
-        <p:nvSpPr>
-          <p:cNvPr id="31" name="TextBox 30"/>
-          <p:cNvSpPr txBox="1"/>
-          <p:nvPr/>
-        </p:nvSpPr>
-        <p:spPr>
-          <a:xfrm>
-            <a:off x="685800" y="5394960"/>
-            <a:ext cx="6400800" cy="274320"/>
-          </a:xfrm>
-          <a:prstGeom prst="rect">
-            <a:avLst/>
-          </a:prstGeom>
-          <a:noFill/>
-        </p:spPr>
-        <p:txBody>
-          <a:bodyPr wrap="square" lIns="0" tIns="0" rIns="0" bIns="0" anchor="t">
-            <a:spAutoFit/>
-          </a:bodyPr>
-          <a:lstStyle/>
-          <a:p>
-            <a:pPr algn="l"/>
-            <a:r>
-              <a:rPr sz="1100" b="0">
-                <a:solidFill>
-                  <a:srgbClr val="0F294B"/>
-                </a:solidFill>
-                <a:latin typeface="Calibri"/>
-              </a:rPr>
-              <a:t>drive them well, so crash rate stays at 33-50 %.</a:t>
-            </a:r>
-          </a:p>
-        </p:txBody>
-      </p:sp>
-      <p:sp>
-        <p:nvSpPr>
-          <p:cNvPr id="32" name="TextBox 31"/>
-          <p:cNvSpPr txBox="1"/>
-          <p:nvPr/>
-        </p:nvSpPr>
-        <p:spPr>
-          <a:xfrm>
-            <a:off x="685800" y="5669280"/>
-            <a:ext cx="6400800" cy="274320"/>
-          </a:xfrm>
-          <a:prstGeom prst="rect">
-            <a:avLst/>
-          </a:prstGeom>
-          <a:noFill/>
-        </p:spPr>
-        <p:txBody>
-          <a:bodyPr wrap="square" lIns="0" tIns="0" rIns="0" bIns="0" anchor="t">
-            <a:spAutoFit/>
-          </a:bodyPr>
-          <a:lstStyle/>
-          <a:p>
-            <a:pPr algn="l"/>
-            <a:endParaRPr/>
-          </a:p>
-        </p:txBody>
-      </p:sp>
-      <p:sp>
-        <p:nvSpPr>
-          <p:cNvPr id="33" name="TextBox 32"/>
-          <p:cNvSpPr txBox="1"/>
-          <p:nvPr/>
-        </p:nvSpPr>
-        <p:spPr>
-          <a:xfrm>
-            <a:off x="685800" y="5943600"/>
-            <a:ext cx="6400800" cy="274320"/>
-          </a:xfrm>
-          <a:prstGeom prst="rect">
-            <a:avLst/>
-          </a:prstGeom>
-          <a:noFill/>
-        </p:spPr>
-        <p:txBody>
-          <a:bodyPr wrap="square" lIns="0" tIns="0" rIns="0" bIns="0" anchor="t">
-            <a:spAutoFit/>
-          </a:bodyPr>
-          <a:lstStyle/>
-          <a:p>
-            <a:pPr algn="l"/>
-            <a:r>
-              <a:rPr sz="1100" b="1">
-                <a:solidFill>
-                  <a:srgbClr val="0F294B"/>
-                </a:solidFill>
-                <a:latin typeface="Calibri"/>
-              </a:rPr>
-              <a:t>Confirms paper's claim is robust on linear merges; open on intersections.</a:t>
-            </a:r>
-          </a:p>
-        </p:txBody>
-      </p:sp>
-      <p:sp>
-        <p:nvSpPr>
-          <p:cNvPr id="34" name="TextBox 33"/>
-          <p:cNvSpPr txBox="1"/>
-          <p:nvPr/>
-        </p:nvSpPr>
-        <p:spPr>
-          <a:xfrm>
-            <a:off x="457200" y="6446520"/>
-            <a:ext cx="10972800" cy="320040"/>
-          </a:xfrm>
-          <a:prstGeom prst="rect">
-            <a:avLst/>
-          </a:prstGeom>
-          <a:noFill/>
-        </p:spPr>
-        <p:txBody>
-          <a:bodyPr wrap="square" lIns="0" tIns="0" rIns="0" bIns="0" anchor="t">
-            <a:spAutoFit/>
-          </a:bodyPr>
-          <a:lstStyle/>
-          <a:p>
-            <a:pPr algn="l"/>
-            <a:r>
-              <a:rPr sz="1000" b="0">
-                <a:solidFill>
-                  <a:srgbClr val="64748B"/>
-                </a:solidFill>
-                <a:latin typeface="Calibri"/>
-              </a:rPr>
-              <a:t>CS 699  ·  Safe RL on Highway-Env  ·  Milestone 3</a:t>
-            </a:r>
-          </a:p>
-        </p:txBody>
-      </p:sp>
-    </p:spTree>
-  </p:cSld>
-  <p:clrMapOvr>
-    <a:masterClrMapping/>
-  </p:clrMapOvr>
-  <p:timing>
-    <p:tnLst>
-      <p:par>
-        <p:cTn id="1" dur="indefinite" restart="never" nodeType="tmRoot">
-          <p:childTnLst>
-            <p:video>
-              <p:cMediaNode vol="80000">
-                <p:cTn id="2" fill="hold" display="0">
-                  <p:stCondLst>
-                    <p:cond delay="indefinite"/>
-                  </p:stCondLst>
-                </p:cTn>
-                <p:tgtEl>
-                  <p:spTgt spid="7"/>
-                </p:tgtEl>
-              </p:cMediaNode>
-            </p:video>
-          </p:childTnLst>
-        </p:cTn>
-      </p:par>
-    </p:tnLst>
-  </p:timing>
-</p:sld>
-</file>
-
-<file path=ppt/slides/slide15.xml><?xml version="1.0" encoding="utf-8"?>
-<p:sld xmlns:a="http://schemas.openxmlformats.org/drawingml/2006/main" xmlns:r="http://schemas.openxmlformats.org/officeDocument/2006/relationships" xmlns:p="http://schemas.openxmlformats.org/presentationml/2006/main">
-  <p:cSld>
-    <p:spTree>
-      <p:nvGrpSpPr>
-        <p:cNvPr id="1" name=""/>
-        <p:cNvGrpSpPr/>
-        <p:nvPr/>
-      </p:nvGrpSpPr>
-      <p:grpSpPr>
-        <a:xfrm>
-          <a:off x="0" y="0"/>
-          <a:ext cx="0" cy="0"/>
-          <a:chOff x="0" y="0"/>
-          <a:chExt cx="0" cy="0"/>
-        </a:xfrm>
-      </p:grpSpPr>
-      <p:sp>
-        <p:nvSpPr>
-          <p:cNvPr id="2" name="Rectangle 1"/>
-          <p:cNvSpPr/>
-          <p:nvPr/>
-        </p:nvSpPr>
-        <p:spPr>
-          <a:xfrm>
-            <a:off x="0" y="0"/>
-            <a:ext cx="12191695" cy="594360"/>
-          </a:xfrm>
-          <a:prstGeom prst="rect">
-            <a:avLst/>
-          </a:prstGeom>
-          <a:solidFill>
-            <a:srgbClr val="0F294B"/>
-          </a:solidFill>
-          <a:ln>
-            <a:noFill/>
-          </a:ln>
-        </p:spPr>
-        <p:style>
-          <a:lnRef idx="1">
-            <a:schemeClr val="accent1"/>
-          </a:lnRef>
-          <a:fillRef idx="3">
-            <a:schemeClr val="accent1"/>
-          </a:fillRef>
-          <a:effectRef idx="2">
-            <a:schemeClr val="accent1"/>
-          </a:effectRef>
-          <a:fontRef idx="minor">
-            <a:schemeClr val="lt1"/>
-          </a:fontRef>
-        </p:style>
-        <p:txBody>
-          <a:bodyPr rtlCol="0" anchor="ctr"/>
-          <a:lstStyle/>
-          <a:p>
-            <a:pPr algn="ctr"/>
-            <a:endParaRPr/>
-          </a:p>
-        </p:txBody>
-      </p:sp>
-      <p:sp>
-        <p:nvSpPr>
-          <p:cNvPr id="3" name="TextBox 2"/>
-          <p:cNvSpPr txBox="1"/>
-          <p:nvPr/>
-        </p:nvSpPr>
-        <p:spPr>
-          <a:xfrm>
-            <a:off x="457200" y="91440"/>
-            <a:ext cx="10058400" cy="457200"/>
-          </a:xfrm>
-          <a:prstGeom prst="rect">
-            <a:avLst/>
-          </a:prstGeom>
-          <a:noFill/>
-        </p:spPr>
-        <p:txBody>
-          <a:bodyPr wrap="square" lIns="0" tIns="0" rIns="0" bIns="0" anchor="t">
-            <a:spAutoFit/>
-          </a:bodyPr>
-          <a:lstStyle/>
-          <a:p>
-            <a:pPr algn="l"/>
-            <a:r>
-              <a:rPr sz="2200" b="1">
-                <a:solidFill>
-                  <a:srgbClr val="FFFFFF"/>
-                </a:solidFill>
-                <a:latin typeface="Calibri"/>
-              </a:rPr>
               <a:t>Take-aways</a:t>
             </a:r>
           </a:p>
@@ -8398,7 +8435,7 @@
 </p:sld>
 </file>
 
-<file path=ppt/slides/slide16.xml><?xml version="1.0" encoding="utf-8"?>
+<file path=ppt/slides/slide15.xml><?xml version="1.0" encoding="utf-8"?>
 <p:sld xmlns:a="http://schemas.openxmlformats.org/drawingml/2006/main" xmlns:r="http://schemas.openxmlformats.org/officeDocument/2006/relationships" xmlns:p="http://schemas.openxmlformats.org/presentationml/2006/main">
   <p:cSld>
     <p:spTree>

</xml_diff>